<commit_message>
Deploying to gh-pages from @ tamanh-oxford/capacity-development@06585f96ee05c2d471b856a1220a2b98fb6a44ab 🚀
</commit_message>
<xml_diff>
--- a/data-frameworks/02-uk-landscape.pptx
+++ b/data-frameworks/02-uk-landscape.pptx
@@ -1,8 +1,8 @@
 
 <file path=ppt/presentation.xml><?xml version="1.0" encoding="utf-8"?>
-<p:presentation xmlns:a="http://schemas.openxmlformats.org/drawingml/2006/main" xmlns:p="http://schemas.openxmlformats.org/presentationml/2006/main" xmlns:r="http://schemas.openxmlformats.org/officeDocument/2006/relationships" autoCompressPictures="0" saveSubsetFonts="1">
+<p:presentation xmlns:a="http://schemas.openxmlformats.org/drawingml/2006/main" xmlns:p="http://schemas.openxmlformats.org/presentationml/2006/main" xmlns:r="http://schemas.openxmlformats.org/officeDocument/2006/relationships" saveSubsetFonts="1" showSpecialPlsOnTitleSld="0">
   <p:sldMasterIdLst>
-    <p:sldMasterId id="2147483648" r:id="rId1"/>
+    <p:sldMasterId id="2147483660" r:id="rId1"/>
   </p:sldMasterIdLst>
   <p:sldIdLst>
     <p:sldId id="256" r:id="rId2"/>
@@ -28,13 +28,13 @@
     <p:sldId id="276" r:id="rId22"/>
     <p:sldId id="277" r:id="rId23"/>
   </p:sldIdLst>
-  <p:sldSz cx="9144000" cy="5143500" type="screen16x9"/>
+  <p:sldSz cx="12192000" cy="6858000"/>
   <p:notesSz cx="6858000" cy="9144000"/>
   <p:defaultTextStyle>
     <a:defPPr>
-      <a:defRPr lang="en-US"/>
+      <a:defRPr lang="en-GB"/>
     </a:defPPr>
-    <a:lvl1pPr algn="l" defTabSz="457200" eaLnBrk="1" hangingPunct="1" latinLnBrk="0" marL="0" rtl="0">
+    <a:lvl1pPr algn="l" defTabSz="914400" eaLnBrk="1" hangingPunct="1" latinLnBrk="0" marL="0" rtl="0">
       <a:defRPr kern="1200" sz="1800">
         <a:solidFill>
           <a:schemeClr val="tx1"/>
@@ -44,7 +44,7 @@
         <a:cs typeface="+mn-cs"/>
       </a:defRPr>
     </a:lvl1pPr>
-    <a:lvl2pPr algn="l" defTabSz="457200" eaLnBrk="1" hangingPunct="1" latinLnBrk="0" marL="457200" rtl="0">
+    <a:lvl2pPr algn="l" defTabSz="914400" eaLnBrk="1" hangingPunct="1" latinLnBrk="0" marL="457200" rtl="0">
       <a:defRPr kern="1200" sz="1800">
         <a:solidFill>
           <a:schemeClr val="tx1"/>
@@ -54,7 +54,7 @@
         <a:cs typeface="+mn-cs"/>
       </a:defRPr>
     </a:lvl2pPr>
-    <a:lvl3pPr algn="l" defTabSz="457200" eaLnBrk="1" hangingPunct="1" latinLnBrk="0" marL="914400" rtl="0">
+    <a:lvl3pPr algn="l" defTabSz="914400" eaLnBrk="1" hangingPunct="1" latinLnBrk="0" marL="914400" rtl="0">
       <a:defRPr kern="1200" sz="1800">
         <a:solidFill>
           <a:schemeClr val="tx1"/>
@@ -64,7 +64,7 @@
         <a:cs typeface="+mn-cs"/>
       </a:defRPr>
     </a:lvl3pPr>
-    <a:lvl4pPr algn="l" defTabSz="457200" eaLnBrk="1" hangingPunct="1" latinLnBrk="0" marL="1371600" rtl="0">
+    <a:lvl4pPr algn="l" defTabSz="914400" eaLnBrk="1" hangingPunct="1" latinLnBrk="0" marL="1371600" rtl="0">
       <a:defRPr kern="1200" sz="1800">
         <a:solidFill>
           <a:schemeClr val="tx1"/>
@@ -74,7 +74,7 @@
         <a:cs typeface="+mn-cs"/>
       </a:defRPr>
     </a:lvl4pPr>
-    <a:lvl5pPr algn="l" defTabSz="457200" eaLnBrk="1" hangingPunct="1" latinLnBrk="0" marL="1828800" rtl="0">
+    <a:lvl5pPr algn="l" defTabSz="914400" eaLnBrk="1" hangingPunct="1" latinLnBrk="0" marL="1828800" rtl="0">
       <a:defRPr kern="1200" sz="1800">
         <a:solidFill>
           <a:schemeClr val="tx1"/>
@@ -84,7 +84,7 @@
         <a:cs typeface="+mn-cs"/>
       </a:defRPr>
     </a:lvl5pPr>
-    <a:lvl6pPr algn="l" defTabSz="457200" eaLnBrk="1" hangingPunct="1" latinLnBrk="0" marL="2286000" rtl="0">
+    <a:lvl6pPr algn="l" defTabSz="914400" eaLnBrk="1" hangingPunct="1" latinLnBrk="0" marL="2286000" rtl="0">
       <a:defRPr kern="1200" sz="1800">
         <a:solidFill>
           <a:schemeClr val="tx1"/>
@@ -94,7 +94,7 @@
         <a:cs typeface="+mn-cs"/>
       </a:defRPr>
     </a:lvl6pPr>
-    <a:lvl7pPr algn="l" defTabSz="457200" eaLnBrk="1" hangingPunct="1" latinLnBrk="0" marL="2743200" rtl="0">
+    <a:lvl7pPr algn="l" defTabSz="914400" eaLnBrk="1" hangingPunct="1" latinLnBrk="0" marL="2743200" rtl="0">
       <a:defRPr kern="1200" sz="1800">
         <a:solidFill>
           <a:schemeClr val="tx1"/>
@@ -104,7 +104,7 @@
         <a:cs typeface="+mn-cs"/>
       </a:defRPr>
     </a:lvl7pPr>
-    <a:lvl8pPr algn="l" defTabSz="457200" eaLnBrk="1" hangingPunct="1" latinLnBrk="0" marL="3200400" rtl="0">
+    <a:lvl8pPr algn="l" defTabSz="914400" eaLnBrk="1" hangingPunct="1" latinLnBrk="0" marL="3200400" rtl="0">
       <a:defRPr kern="1200" sz="1800">
         <a:solidFill>
           <a:schemeClr val="tx1"/>
@@ -114,7 +114,7 @@
         <a:cs typeface="+mn-cs"/>
       </a:defRPr>
     </a:lvl8pPr>
-    <a:lvl9pPr algn="l" defTabSz="457200" eaLnBrk="1" hangingPunct="1" latinLnBrk="0" marL="3657600" rtl="0">
+    <a:lvl9pPr algn="l" defTabSz="914400" eaLnBrk="1" hangingPunct="1" latinLnBrk="0" marL="3657600" rtl="0">
       <a:defRPr kern="1200" sz="1800">
         <a:solidFill>
           <a:schemeClr val="tx1"/>
@@ -127,18 +127,7 @@
   </p:defaultTextStyle>
   <p:extLst>
     <p:ext uri="{EFAFB233-063F-42B5-8137-9DF3F51BA10A}">
-      <p15:sldGuideLst xmlns:p15="http://schemas.microsoft.com/office/powerpoint/2012/main">
-        <p15:guide id="1" orient="horz" pos="1620" userDrawn="1">
-          <p15:clr>
-            <a:srgbClr val="A4A3A4"/>
-          </p15:clr>
-        </p15:guide>
-        <p15:guide id="2" pos="2880" userDrawn="1">
-          <p15:clr>
-            <a:srgbClr val="A4A3A4"/>
-          </p15:clr>
-        </p15:guide>
-      </p15:sldGuideLst>
+      <p15:sldGuideLst xmlns:p15="http://schemas.microsoft.com/office/powerpoint/2012/main"/>
     </p:ext>
   </p:extLst>
 </p:presentation>
@@ -173,18 +162,23 @@
         </p:nvSpPr>
         <p:spPr>
           <a:xfrm>
-            <a:off x="685800" y="1597819"/>
-            <a:ext cx="7772400" cy="1102519"/>
+            <a:off x="1524000" y="1122363"/>
+            <a:ext cx="9144000" cy="2387600"/>
           </a:xfrm>
         </p:spPr>
         <p:txBody>
-          <a:bodyPr/>
-          <a:lstStyle/>
-          <a:p>
-            <a:r>
-              <a:rPr lang="en-US"/>
+          <a:bodyPr anchor="b"/>
+          <a:lstStyle>
+            <a:lvl1pPr algn="ctr">
+              <a:defRPr sz="6000"/>
+            </a:lvl1pPr>
+          </a:lstStyle>
+          <a:p>
+            <a:r>
+              <a:rPr lang="en-GB"/>
               <a:t>Click to edit Master title style</a:t>
             </a:r>
+            <a:endParaRPr lang="en-GB" dirty="0"/>
           </a:p>
         </p:txBody>
       </p:sp>
@@ -200,8 +194,8 @@
         </p:nvSpPr>
         <p:spPr>
           <a:xfrm>
-            <a:off x="1371600" y="2914650"/>
-            <a:ext cx="6400800" cy="1314450"/>
+            <a:off x="1524000" y="3602038"/>
+            <a:ext cx="9144000" cy="1655762"/>
           </a:xfrm>
         </p:spPr>
         <p:txBody>
@@ -209,100 +203,47 @@
           <a:lstStyle>
             <a:lvl1pPr marL="0" indent="0" algn="ctr">
               <a:buNone/>
-              <a:defRPr>
-                <a:solidFill>
-                  <a:schemeClr val="tx1">
-                    <a:tint val="75000"/>
-                  </a:schemeClr>
-                </a:solidFill>
-              </a:defRPr>
+              <a:defRPr sz="2400"/>
             </a:lvl1pPr>
-            <a:lvl2pPr marL="342900" indent="0" algn="ctr">
-              <a:buNone/>
-              <a:defRPr>
-                <a:solidFill>
-                  <a:schemeClr val="tx1">
-                    <a:tint val="75000"/>
-                  </a:schemeClr>
-                </a:solidFill>
-              </a:defRPr>
+            <a:lvl2pPr marL="457200" indent="0" algn="ctr">
+              <a:buNone/>
+              <a:defRPr sz="2000"/>
             </a:lvl2pPr>
-            <a:lvl3pPr marL="685800" indent="0" algn="ctr">
-              <a:buNone/>
-              <a:defRPr>
-                <a:solidFill>
-                  <a:schemeClr val="tx1">
-                    <a:tint val="75000"/>
-                  </a:schemeClr>
-                </a:solidFill>
-              </a:defRPr>
+            <a:lvl3pPr marL="914400" indent="0" algn="ctr">
+              <a:buNone/>
+              <a:defRPr sz="1800"/>
             </a:lvl3pPr>
-            <a:lvl4pPr marL="1028700" indent="0" algn="ctr">
-              <a:buNone/>
-              <a:defRPr>
-                <a:solidFill>
-                  <a:schemeClr val="tx1">
-                    <a:tint val="75000"/>
-                  </a:schemeClr>
-                </a:solidFill>
-              </a:defRPr>
+            <a:lvl4pPr marL="1371600" indent="0" algn="ctr">
+              <a:buNone/>
+              <a:defRPr sz="1600"/>
             </a:lvl4pPr>
-            <a:lvl5pPr marL="1371600" indent="0" algn="ctr">
-              <a:buNone/>
-              <a:defRPr>
-                <a:solidFill>
-                  <a:schemeClr val="tx1">
-                    <a:tint val="75000"/>
-                  </a:schemeClr>
-                </a:solidFill>
-              </a:defRPr>
+            <a:lvl5pPr marL="1828800" indent="0" algn="ctr">
+              <a:buNone/>
+              <a:defRPr sz="1600"/>
             </a:lvl5pPr>
-            <a:lvl6pPr marL="1714500" indent="0" algn="ctr">
-              <a:buNone/>
-              <a:defRPr>
-                <a:solidFill>
-                  <a:schemeClr val="tx1">
-                    <a:tint val="75000"/>
-                  </a:schemeClr>
-                </a:solidFill>
-              </a:defRPr>
+            <a:lvl6pPr marL="2286000" indent="0" algn="ctr">
+              <a:buNone/>
+              <a:defRPr sz="1600"/>
             </a:lvl6pPr>
-            <a:lvl7pPr marL="2057400" indent="0" algn="ctr">
-              <a:buNone/>
-              <a:defRPr>
-                <a:solidFill>
-                  <a:schemeClr val="tx1">
-                    <a:tint val="75000"/>
-                  </a:schemeClr>
-                </a:solidFill>
-              </a:defRPr>
+            <a:lvl7pPr marL="2743200" indent="0" algn="ctr">
+              <a:buNone/>
+              <a:defRPr sz="1600"/>
             </a:lvl7pPr>
-            <a:lvl8pPr marL="2400300" indent="0" algn="ctr">
-              <a:buNone/>
-              <a:defRPr>
-                <a:solidFill>
-                  <a:schemeClr val="tx1">
-                    <a:tint val="75000"/>
-                  </a:schemeClr>
-                </a:solidFill>
-              </a:defRPr>
+            <a:lvl8pPr marL="3200400" indent="0" algn="ctr">
+              <a:buNone/>
+              <a:defRPr sz="1600"/>
             </a:lvl8pPr>
-            <a:lvl9pPr marL="2743200" indent="0" algn="ctr">
-              <a:buNone/>
-              <a:defRPr>
-                <a:solidFill>
-                  <a:schemeClr val="tx1">
-                    <a:tint val="75000"/>
-                  </a:schemeClr>
-                </a:solidFill>
-              </a:defRPr>
+            <a:lvl9pPr marL="3657600" indent="0" algn="ctr">
+              <a:buNone/>
+              <a:defRPr sz="1600"/>
             </a:lvl9pPr>
           </a:lstStyle>
           <a:p>
             <a:r>
-              <a:rPr lang="en-US"/>
+              <a:rPr lang="en-GB"/>
               <a:t>Click to edit Master subtitle style</a:t>
             </a:r>
+            <a:endParaRPr lang="en-GB" dirty="0"/>
           </a:p>
         </p:txBody>
       </p:sp>
@@ -321,11 +262,11 @@
           <a:bodyPr/>
           <a:lstStyle/>
           <a:p>
-            <a:fld id="{241EB5C9-1307-BA42-ABA2-0BC069CD8E7F}" type="datetimeFigureOut">
-              <a:rPr lang="en-US" smtClean="0"/>
-              <a:t>1/2/22</a:t>
+            <a:fld id="{846CE7D5-CF57-46EF-B807-FDD0502418D4}" type="datetimeFigureOut">
+              <a:rPr lang="en-GB" smtClean="0"/>
+              <a:t>13/01/2026</a:t>
             </a:fld>
-            <a:endParaRPr lang="en-US"/>
+            <a:endParaRPr lang="en-GB"/>
           </a:p>
         </p:txBody>
       </p:sp>
@@ -344,7 +285,10 @@
           <a:bodyPr/>
           <a:lstStyle/>
           <a:p>
-            <a:endParaRPr lang="en-US"/>
+            <a:r>
+              <a:rPr lang="en-GB"/>
+              <a:t>Tâm Anh Oxford Partnership</a:t>
+            </a:r>
           </a:p>
         </p:txBody>
       </p:sp>
@@ -363,24 +307,25 @@
           <a:bodyPr/>
           <a:lstStyle/>
           <a:p>
-            <a:fld id="{C5EF2332-01BF-834F-8236-50238282D533}" type="slidenum">
-              <a:rPr lang="en-US" smtClean="0"/>
+            <a:fld id="{330EA680-D336-4FF7-8B7A-9848BB0A1C32}" type="slidenum">
+              <a:rPr lang="en-GB" smtClean="0"/>
               <a:t>‹#›</a:t>
             </a:fld>
-            <a:endParaRPr lang="en-US"/>
+            <a:endParaRPr lang="en-GB"/>
           </a:p>
         </p:txBody>
       </p:sp>
     </p:spTree>
     <p:extLst>
       <p:ext uri="{BB962C8B-B14F-4D97-AF65-F5344CB8AC3E}">
-        <p14:creationId xmlns:p14="http://schemas.microsoft.com/office/powerpoint/2010/main" val="1444357513"/>
+        <p14:creationId xmlns:p14="http://schemas.microsoft.com/office/powerpoint/2010/main" val="2385387890"/>
       </p:ext>
     </p:extLst>
   </p:cSld>
   <p:clrMapOvr>
     <a:masterClrMapping/>
   </p:clrMapOvr>
+  <p:hf sldNum="0" hdr="0" ftr="0" dt="0"/>
 </p:sldLayout>
 </file>
 
@@ -417,9 +362,10 @@
           <a:lstStyle/>
           <a:p>
             <a:r>
-              <a:rPr lang="en-US"/>
+              <a:rPr lang="en-GB"/>
               <a:t>Click to edit Master title style</a:t>
             </a:r>
+            <a:endParaRPr lang="en-GB" dirty="0"/>
           </a:p>
         </p:txBody>
       </p:sp>
@@ -440,37 +386,38 @@
           <a:p>
             <a:pPr lvl="0"/>
             <a:r>
-              <a:rPr lang="en-US"/>
+              <a:rPr lang="en-GB"/>
               <a:t>Click to edit Master text styles</a:t>
             </a:r>
           </a:p>
           <a:p>
             <a:pPr lvl="1"/>
             <a:r>
-              <a:rPr lang="en-US"/>
+              <a:rPr lang="en-GB"/>
               <a:t>Second level</a:t>
             </a:r>
           </a:p>
           <a:p>
             <a:pPr lvl="2"/>
             <a:r>
-              <a:rPr lang="en-US"/>
+              <a:rPr lang="en-GB"/>
               <a:t>Third level</a:t>
             </a:r>
           </a:p>
           <a:p>
             <a:pPr lvl="3"/>
             <a:r>
-              <a:rPr lang="en-US"/>
+              <a:rPr lang="en-GB"/>
               <a:t>Fourth level</a:t>
             </a:r>
           </a:p>
           <a:p>
             <a:pPr lvl="4"/>
             <a:r>
-              <a:rPr lang="en-US"/>
+              <a:rPr lang="en-GB"/>
               <a:t>Fifth level</a:t>
             </a:r>
+            <a:endParaRPr lang="en-GB" dirty="0"/>
           </a:p>
         </p:txBody>
       </p:sp>
@@ -489,11 +436,11 @@
           <a:bodyPr/>
           <a:lstStyle/>
           <a:p>
-            <a:fld id="{241EB5C9-1307-BA42-ABA2-0BC069CD8E7F}" type="datetimeFigureOut">
-              <a:rPr lang="en-US" smtClean="0"/>
-              <a:t>1/2/22</a:t>
+            <a:fld id="{846CE7D5-CF57-46EF-B807-FDD0502418D4}" type="datetimeFigureOut">
+              <a:rPr lang="en-GB" smtClean="0"/>
+              <a:t>13/01/2026</a:t>
             </a:fld>
-            <a:endParaRPr lang="en-US"/>
+            <a:endParaRPr lang="en-GB"/>
           </a:p>
         </p:txBody>
       </p:sp>
@@ -512,7 +459,10 @@
           <a:bodyPr/>
           <a:lstStyle/>
           <a:p>
-            <a:endParaRPr lang="en-US"/>
+            <a:r>
+              <a:rPr lang="en-GB"/>
+              <a:t>Tâm Anh Oxford Partnership</a:t>
+            </a:r>
           </a:p>
         </p:txBody>
       </p:sp>
@@ -531,24 +481,25 @@
           <a:bodyPr/>
           <a:lstStyle/>
           <a:p>
-            <a:fld id="{C5EF2332-01BF-834F-8236-50238282D533}" type="slidenum">
-              <a:rPr lang="en-US" smtClean="0"/>
+            <a:fld id="{330EA680-D336-4FF7-8B7A-9848BB0A1C32}" type="slidenum">
+              <a:rPr lang="en-GB" smtClean="0"/>
               <a:t>‹#›</a:t>
             </a:fld>
-            <a:endParaRPr lang="en-US"/>
+            <a:endParaRPr lang="en-GB"/>
           </a:p>
         </p:txBody>
       </p:sp>
     </p:spTree>
     <p:extLst>
       <p:ext uri="{BB962C8B-B14F-4D97-AF65-F5344CB8AC3E}">
-        <p14:creationId xmlns:p14="http://schemas.microsoft.com/office/powerpoint/2010/main" val="313914798"/>
+        <p14:creationId xmlns:p14="http://schemas.microsoft.com/office/powerpoint/2010/main" val="2202905451"/>
       </p:ext>
     </p:extLst>
   </p:cSld>
   <p:clrMapOvr>
     <a:masterClrMapping/>
   </p:clrMapOvr>
+  <p:hf hdr="0" dt="0"/>
 </p:sldLayout>
 </file>
 
@@ -581,8 +532,8 @@
         </p:nvSpPr>
         <p:spPr>
           <a:xfrm>
-            <a:off x="6629400" y="205979"/>
-            <a:ext cx="2057400" cy="4388644"/>
+            <a:off x="8724900" y="365125"/>
+            <a:ext cx="2628900" cy="5811838"/>
           </a:xfrm>
         </p:spPr>
         <p:txBody>
@@ -590,9 +541,10 @@
           <a:lstStyle/>
           <a:p>
             <a:r>
-              <a:rPr lang="en-US"/>
+              <a:rPr lang="en-GB"/>
               <a:t>Click to edit Master title style</a:t>
             </a:r>
+            <a:endParaRPr lang="en-GB" dirty="0"/>
           </a:p>
         </p:txBody>
       </p:sp>
@@ -608,8 +560,8 @@
         </p:nvSpPr>
         <p:spPr>
           <a:xfrm>
-            <a:off x="457200" y="205979"/>
-            <a:ext cx="6019800" cy="4388644"/>
+            <a:off x="838200" y="365125"/>
+            <a:ext cx="7734300" cy="5811838"/>
           </a:xfrm>
         </p:spPr>
         <p:txBody>
@@ -618,37 +570,38 @@
           <a:p>
             <a:pPr lvl="0"/>
             <a:r>
-              <a:rPr lang="en-US"/>
+              <a:rPr lang="en-GB"/>
               <a:t>Click to edit Master text styles</a:t>
             </a:r>
           </a:p>
           <a:p>
             <a:pPr lvl="1"/>
             <a:r>
-              <a:rPr lang="en-US"/>
+              <a:rPr lang="en-GB"/>
               <a:t>Second level</a:t>
             </a:r>
           </a:p>
           <a:p>
             <a:pPr lvl="2"/>
             <a:r>
-              <a:rPr lang="en-US"/>
+              <a:rPr lang="en-GB"/>
               <a:t>Third level</a:t>
             </a:r>
           </a:p>
           <a:p>
             <a:pPr lvl="3"/>
             <a:r>
-              <a:rPr lang="en-US"/>
+              <a:rPr lang="en-GB"/>
               <a:t>Fourth level</a:t>
             </a:r>
           </a:p>
           <a:p>
             <a:pPr lvl="4"/>
             <a:r>
-              <a:rPr lang="en-US"/>
+              <a:rPr lang="en-GB"/>
               <a:t>Fifth level</a:t>
             </a:r>
+            <a:endParaRPr lang="en-GB" dirty="0"/>
           </a:p>
         </p:txBody>
       </p:sp>
@@ -667,11 +620,11 @@
           <a:bodyPr/>
           <a:lstStyle/>
           <a:p>
-            <a:fld id="{241EB5C9-1307-BA42-ABA2-0BC069CD8E7F}" type="datetimeFigureOut">
-              <a:rPr lang="en-US" smtClean="0"/>
-              <a:t>1/2/22</a:t>
+            <a:fld id="{846CE7D5-CF57-46EF-B807-FDD0502418D4}" type="datetimeFigureOut">
+              <a:rPr lang="en-GB" smtClean="0"/>
+              <a:t>13/01/2026</a:t>
             </a:fld>
-            <a:endParaRPr lang="en-US"/>
+            <a:endParaRPr lang="en-GB"/>
           </a:p>
         </p:txBody>
       </p:sp>
@@ -690,7 +643,10 @@
           <a:bodyPr/>
           <a:lstStyle/>
           <a:p>
-            <a:endParaRPr lang="en-US"/>
+            <a:r>
+              <a:rPr lang="en-GB"/>
+              <a:t>Tâm Anh Oxford Partnership</a:t>
+            </a:r>
           </a:p>
         </p:txBody>
       </p:sp>
@@ -709,24 +665,25 @@
           <a:bodyPr/>
           <a:lstStyle/>
           <a:p>
-            <a:fld id="{C5EF2332-01BF-834F-8236-50238282D533}" type="slidenum">
-              <a:rPr lang="en-US" smtClean="0"/>
+            <a:fld id="{330EA680-D336-4FF7-8B7A-9848BB0A1C32}" type="slidenum">
+              <a:rPr lang="en-GB" smtClean="0"/>
               <a:t>‹#›</a:t>
             </a:fld>
-            <a:endParaRPr lang="en-US"/>
+            <a:endParaRPr lang="en-GB"/>
           </a:p>
         </p:txBody>
       </p:sp>
     </p:spTree>
     <p:extLst>
       <p:ext uri="{BB962C8B-B14F-4D97-AF65-F5344CB8AC3E}">
-        <p14:creationId xmlns:p14="http://schemas.microsoft.com/office/powerpoint/2010/main" val="2581529045"/>
+        <p14:creationId xmlns:p14="http://schemas.microsoft.com/office/powerpoint/2010/main" val="3479445657"/>
       </p:ext>
     </p:extLst>
   </p:cSld>
   <p:clrMapOvr>
     <a:masterClrMapping/>
   </p:clrMapOvr>
+  <p:hf hdr="0" dt="0"/>
 </p:sldLayout>
 </file>
 
@@ -763,9 +720,10 @@
           <a:lstStyle/>
           <a:p>
             <a:r>
-              <a:rPr lang="en-US"/>
+              <a:rPr lang="en-GB"/>
               <a:t>Click to edit Master title style</a:t>
             </a:r>
+            <a:endParaRPr lang="en-GB" dirty="0"/>
           </a:p>
         </p:txBody>
       </p:sp>
@@ -786,37 +744,38 @@
           <a:p>
             <a:pPr lvl="0"/>
             <a:r>
-              <a:rPr lang="en-US"/>
+              <a:rPr lang="en-GB"/>
               <a:t>Click to edit Master text styles</a:t>
             </a:r>
           </a:p>
           <a:p>
             <a:pPr lvl="1"/>
             <a:r>
-              <a:rPr lang="en-US"/>
+              <a:rPr lang="en-GB"/>
               <a:t>Second level</a:t>
             </a:r>
           </a:p>
           <a:p>
             <a:pPr lvl="2"/>
             <a:r>
-              <a:rPr lang="en-US"/>
+              <a:rPr lang="en-GB"/>
               <a:t>Third level</a:t>
             </a:r>
           </a:p>
           <a:p>
             <a:pPr lvl="3"/>
             <a:r>
-              <a:rPr lang="en-US"/>
+              <a:rPr lang="en-GB"/>
               <a:t>Fourth level</a:t>
             </a:r>
           </a:p>
           <a:p>
             <a:pPr lvl="4"/>
             <a:r>
-              <a:rPr lang="en-US"/>
+              <a:rPr lang="en-GB"/>
               <a:t>Fifth level</a:t>
             </a:r>
+            <a:endParaRPr lang="en-GB" dirty="0"/>
           </a:p>
         </p:txBody>
       </p:sp>
@@ -835,11 +794,11 @@
           <a:bodyPr/>
           <a:lstStyle/>
           <a:p>
-            <a:fld id="{241EB5C9-1307-BA42-ABA2-0BC069CD8E7F}" type="datetimeFigureOut">
-              <a:rPr lang="en-US" smtClean="0"/>
-              <a:t>1/2/22</a:t>
+            <a:fld id="{846CE7D5-CF57-46EF-B807-FDD0502418D4}" type="datetimeFigureOut">
+              <a:rPr lang="en-GB" smtClean="0"/>
+              <a:t>13/01/2026</a:t>
             </a:fld>
-            <a:endParaRPr lang="en-US"/>
+            <a:endParaRPr lang="en-GB"/>
           </a:p>
         </p:txBody>
       </p:sp>
@@ -858,7 +817,10 @@
           <a:bodyPr/>
           <a:lstStyle/>
           <a:p>
-            <a:endParaRPr lang="en-US"/>
+            <a:r>
+              <a:rPr lang="en-GB"/>
+              <a:t>Tâm Anh Oxford Partnership</a:t>
+            </a:r>
           </a:p>
         </p:txBody>
       </p:sp>
@@ -877,24 +839,25 @@
           <a:bodyPr/>
           <a:lstStyle/>
           <a:p>
-            <a:fld id="{C5EF2332-01BF-834F-8236-50238282D533}" type="slidenum">
-              <a:rPr lang="en-US" smtClean="0"/>
+            <a:fld id="{330EA680-D336-4FF7-8B7A-9848BB0A1C32}" type="slidenum">
+              <a:rPr lang="en-GB" smtClean="0"/>
               <a:t>‹#›</a:t>
             </a:fld>
-            <a:endParaRPr lang="en-US"/>
+            <a:endParaRPr lang="en-GB"/>
           </a:p>
         </p:txBody>
       </p:sp>
     </p:spTree>
     <p:extLst>
       <p:ext uri="{BB962C8B-B14F-4D97-AF65-F5344CB8AC3E}">
-        <p14:creationId xmlns:p14="http://schemas.microsoft.com/office/powerpoint/2010/main" val="338346009"/>
+        <p14:creationId xmlns:p14="http://schemas.microsoft.com/office/powerpoint/2010/main" val="949138452"/>
       </p:ext>
     </p:extLst>
   </p:cSld>
   <p:clrMapOvr>
     <a:masterClrMapping/>
   </p:clrMapOvr>
+  <p:hf hdr="0" dt="0"/>
 </p:sldLayout>
 </file>
 
@@ -927,22 +890,23 @@
         </p:nvSpPr>
         <p:spPr>
           <a:xfrm>
-            <a:off x="722313" y="3305176"/>
-            <a:ext cx="7772400" cy="1021556"/>
+            <a:off x="831850" y="1709738"/>
+            <a:ext cx="10515600" cy="2852737"/>
           </a:xfrm>
         </p:spPr>
         <p:txBody>
-          <a:bodyPr anchor="t"/>
+          <a:bodyPr anchor="b"/>
           <a:lstStyle>
-            <a:lvl1pPr algn="l">
-              <a:defRPr sz="3000" b="1" cap="all"/>
+            <a:lvl1pPr>
+              <a:defRPr sz="6000"/>
             </a:lvl1pPr>
           </a:lstStyle>
           <a:p>
             <a:r>
-              <a:rPr lang="en-US"/>
+              <a:rPr lang="en-GB"/>
               <a:t>Click to edit Master title style</a:t>
             </a:r>
+            <a:endParaRPr lang="en-GB" dirty="0"/>
           </a:p>
         </p:txBody>
       </p:sp>
@@ -958,99 +922,99 @@
         </p:nvSpPr>
         <p:spPr>
           <a:xfrm>
-            <a:off x="722313" y="2180035"/>
-            <a:ext cx="7772400" cy="1125140"/>
+            <a:off x="831850" y="4589463"/>
+            <a:ext cx="10515600" cy="1500187"/>
           </a:xfrm>
         </p:spPr>
         <p:txBody>
-          <a:bodyPr anchor="b"/>
+          <a:bodyPr/>
           <a:lstStyle>
             <a:lvl1pPr marL="0" indent="0">
               <a:buNone/>
-              <a:defRPr sz="1500">
+              <a:defRPr sz="2400">
                 <a:solidFill>
                   <a:schemeClr val="tx1">
-                    <a:tint val="75000"/>
+                    <a:tint val="82000"/>
                   </a:schemeClr>
                 </a:solidFill>
               </a:defRPr>
             </a:lvl1pPr>
-            <a:lvl2pPr marL="342900" indent="0">
-              <a:buNone/>
-              <a:defRPr sz="1350">
+            <a:lvl2pPr marL="457200" indent="0">
+              <a:buNone/>
+              <a:defRPr sz="2000">
                 <a:solidFill>
                   <a:schemeClr val="tx1">
-                    <a:tint val="75000"/>
+                    <a:tint val="82000"/>
                   </a:schemeClr>
                 </a:solidFill>
               </a:defRPr>
             </a:lvl2pPr>
-            <a:lvl3pPr marL="685800" indent="0">
-              <a:buNone/>
-              <a:defRPr sz="1200">
+            <a:lvl3pPr marL="914400" indent="0">
+              <a:buNone/>
+              <a:defRPr sz="1800">
                 <a:solidFill>
                   <a:schemeClr val="tx1">
-                    <a:tint val="75000"/>
+                    <a:tint val="82000"/>
                   </a:schemeClr>
                 </a:solidFill>
               </a:defRPr>
             </a:lvl3pPr>
-            <a:lvl4pPr marL="1028700" indent="0">
-              <a:buNone/>
-              <a:defRPr sz="1050">
+            <a:lvl4pPr marL="1371600" indent="0">
+              <a:buNone/>
+              <a:defRPr sz="1600">
                 <a:solidFill>
                   <a:schemeClr val="tx1">
-                    <a:tint val="75000"/>
+                    <a:tint val="82000"/>
                   </a:schemeClr>
                 </a:solidFill>
               </a:defRPr>
             </a:lvl4pPr>
-            <a:lvl5pPr marL="1371600" indent="0">
-              <a:buNone/>
-              <a:defRPr sz="1050">
+            <a:lvl5pPr marL="1828800" indent="0">
+              <a:buNone/>
+              <a:defRPr sz="1600">
                 <a:solidFill>
                   <a:schemeClr val="tx1">
-                    <a:tint val="75000"/>
+                    <a:tint val="82000"/>
                   </a:schemeClr>
                 </a:solidFill>
               </a:defRPr>
             </a:lvl5pPr>
-            <a:lvl6pPr marL="1714500" indent="0">
-              <a:buNone/>
-              <a:defRPr sz="1050">
+            <a:lvl6pPr marL="2286000" indent="0">
+              <a:buNone/>
+              <a:defRPr sz="1600">
                 <a:solidFill>
                   <a:schemeClr val="tx1">
-                    <a:tint val="75000"/>
+                    <a:tint val="82000"/>
                   </a:schemeClr>
                 </a:solidFill>
               </a:defRPr>
             </a:lvl6pPr>
-            <a:lvl7pPr marL="2057400" indent="0">
-              <a:buNone/>
-              <a:defRPr sz="1050">
+            <a:lvl7pPr marL="2743200" indent="0">
+              <a:buNone/>
+              <a:defRPr sz="1600">
                 <a:solidFill>
                   <a:schemeClr val="tx1">
-                    <a:tint val="75000"/>
+                    <a:tint val="82000"/>
                   </a:schemeClr>
                 </a:solidFill>
               </a:defRPr>
             </a:lvl7pPr>
-            <a:lvl8pPr marL="2400300" indent="0">
-              <a:buNone/>
-              <a:defRPr sz="1050">
+            <a:lvl8pPr marL="3200400" indent="0">
+              <a:buNone/>
+              <a:defRPr sz="1600">
                 <a:solidFill>
                   <a:schemeClr val="tx1">
-                    <a:tint val="75000"/>
+                    <a:tint val="82000"/>
                   </a:schemeClr>
                 </a:solidFill>
               </a:defRPr>
             </a:lvl8pPr>
-            <a:lvl9pPr marL="2743200" indent="0">
-              <a:buNone/>
-              <a:defRPr sz="1050">
+            <a:lvl9pPr marL="3657600" indent="0">
+              <a:buNone/>
+              <a:defRPr sz="1600">
                 <a:solidFill>
                   <a:schemeClr val="tx1">
-                    <a:tint val="75000"/>
+                    <a:tint val="82000"/>
                   </a:schemeClr>
                 </a:solidFill>
               </a:defRPr>
@@ -1059,7 +1023,7 @@
           <a:p>
             <a:pPr lvl="0"/>
             <a:r>
-              <a:rPr lang="en-US"/>
+              <a:rPr lang="en-GB"/>
               <a:t>Click to edit Master text styles</a:t>
             </a:r>
           </a:p>
@@ -1080,11 +1044,11 @@
           <a:bodyPr/>
           <a:lstStyle/>
           <a:p>
-            <a:fld id="{241EB5C9-1307-BA42-ABA2-0BC069CD8E7F}" type="datetimeFigureOut">
-              <a:rPr lang="en-US" smtClean="0"/>
-              <a:t>1/2/22</a:t>
+            <a:fld id="{846CE7D5-CF57-46EF-B807-FDD0502418D4}" type="datetimeFigureOut">
+              <a:rPr lang="en-GB" smtClean="0"/>
+              <a:t>13/01/2026</a:t>
             </a:fld>
-            <a:endParaRPr lang="en-US"/>
+            <a:endParaRPr lang="en-GB"/>
           </a:p>
         </p:txBody>
       </p:sp>
@@ -1103,7 +1067,10 @@
           <a:bodyPr/>
           <a:lstStyle/>
           <a:p>
-            <a:endParaRPr lang="en-US"/>
+            <a:r>
+              <a:rPr lang="en-GB"/>
+              <a:t>Tâm Anh Oxford Partnership</a:t>
+            </a:r>
           </a:p>
         </p:txBody>
       </p:sp>
@@ -1122,24 +1089,25 @@
           <a:bodyPr/>
           <a:lstStyle/>
           <a:p>
-            <a:fld id="{C5EF2332-01BF-834F-8236-50238282D533}" type="slidenum">
-              <a:rPr lang="en-US" smtClean="0"/>
+            <a:fld id="{330EA680-D336-4FF7-8B7A-9848BB0A1C32}" type="slidenum">
+              <a:rPr lang="en-GB" smtClean="0"/>
               <a:t>‹#›</a:t>
             </a:fld>
-            <a:endParaRPr lang="en-US"/>
+            <a:endParaRPr lang="en-GB"/>
           </a:p>
         </p:txBody>
       </p:sp>
     </p:spTree>
     <p:extLst>
       <p:ext uri="{BB962C8B-B14F-4D97-AF65-F5344CB8AC3E}">
-        <p14:creationId xmlns:p14="http://schemas.microsoft.com/office/powerpoint/2010/main" val="1073069076"/>
+        <p14:creationId xmlns:p14="http://schemas.microsoft.com/office/powerpoint/2010/main" val="2591524520"/>
       </p:ext>
     </p:extLst>
   </p:cSld>
   <p:clrMapOvr>
     <a:masterClrMapping/>
   </p:clrMapOvr>
+  <p:hf hdr="0" dt="0"/>
 </p:sldLayout>
 </file>
 
@@ -1176,9 +1144,10 @@
           <a:lstStyle/>
           <a:p>
             <a:r>
-              <a:rPr lang="en-US"/>
+              <a:rPr lang="en-GB"/>
               <a:t>Click to edit Master title style</a:t>
             </a:r>
+            <a:endParaRPr lang="en-GB" dirty="0"/>
           </a:p>
         </p:txBody>
       </p:sp>
@@ -1194,75 +1163,48 @@
         </p:nvSpPr>
         <p:spPr>
           <a:xfrm>
-            <a:off x="457200" y="1200151"/>
-            <a:ext cx="4038600" cy="3394472"/>
+            <a:off x="838200" y="1825625"/>
+            <a:ext cx="5181600" cy="4351338"/>
           </a:xfrm>
         </p:spPr>
         <p:txBody>
           <a:bodyPr/>
-          <a:lstStyle>
-            <a:lvl1pPr>
-              <a:defRPr sz="2100"/>
-            </a:lvl1pPr>
-            <a:lvl2pPr>
-              <a:defRPr sz="1800"/>
-            </a:lvl2pPr>
-            <a:lvl3pPr>
-              <a:defRPr sz="1500"/>
-            </a:lvl3pPr>
-            <a:lvl4pPr>
-              <a:defRPr sz="1350"/>
-            </a:lvl4pPr>
-            <a:lvl5pPr>
-              <a:defRPr sz="1350"/>
-            </a:lvl5pPr>
-            <a:lvl6pPr>
-              <a:defRPr sz="1350"/>
-            </a:lvl6pPr>
-            <a:lvl7pPr>
-              <a:defRPr sz="1350"/>
-            </a:lvl7pPr>
-            <a:lvl8pPr>
-              <a:defRPr sz="1350"/>
-            </a:lvl8pPr>
-            <a:lvl9pPr>
-              <a:defRPr sz="1350"/>
-            </a:lvl9pPr>
-          </a:lstStyle>
-          <a:p>
-            <a:pPr lvl="0"/>
-            <a:r>
-              <a:rPr lang="en-US"/>
+          <a:lstStyle/>
+          <a:p>
+            <a:pPr lvl="0"/>
+            <a:r>
+              <a:rPr lang="en-GB"/>
               <a:t>Click to edit Master text styles</a:t>
             </a:r>
           </a:p>
           <a:p>
             <a:pPr lvl="1"/>
             <a:r>
-              <a:rPr lang="en-US"/>
+              <a:rPr lang="en-GB"/>
               <a:t>Second level</a:t>
             </a:r>
           </a:p>
           <a:p>
             <a:pPr lvl="2"/>
             <a:r>
-              <a:rPr lang="en-US"/>
+              <a:rPr lang="en-GB"/>
               <a:t>Third level</a:t>
             </a:r>
           </a:p>
           <a:p>
             <a:pPr lvl="3"/>
             <a:r>
-              <a:rPr lang="en-US"/>
+              <a:rPr lang="en-GB"/>
               <a:t>Fourth level</a:t>
             </a:r>
           </a:p>
           <a:p>
             <a:pPr lvl="4"/>
             <a:r>
-              <a:rPr lang="en-US"/>
+              <a:rPr lang="en-GB"/>
               <a:t>Fifth level</a:t>
             </a:r>
+            <a:endParaRPr lang="en-GB" dirty="0"/>
           </a:p>
         </p:txBody>
       </p:sp>
@@ -1278,75 +1220,48 @@
         </p:nvSpPr>
         <p:spPr>
           <a:xfrm>
-            <a:off x="4648200" y="1200151"/>
-            <a:ext cx="4038600" cy="3394472"/>
+            <a:off x="6172200" y="1825625"/>
+            <a:ext cx="5181600" cy="4351338"/>
           </a:xfrm>
         </p:spPr>
         <p:txBody>
           <a:bodyPr/>
-          <a:lstStyle>
-            <a:lvl1pPr>
-              <a:defRPr sz="2100"/>
-            </a:lvl1pPr>
-            <a:lvl2pPr>
-              <a:defRPr sz="1800"/>
-            </a:lvl2pPr>
-            <a:lvl3pPr>
-              <a:defRPr sz="1500"/>
-            </a:lvl3pPr>
-            <a:lvl4pPr>
-              <a:defRPr sz="1350"/>
-            </a:lvl4pPr>
-            <a:lvl5pPr>
-              <a:defRPr sz="1350"/>
-            </a:lvl5pPr>
-            <a:lvl6pPr>
-              <a:defRPr sz="1350"/>
-            </a:lvl6pPr>
-            <a:lvl7pPr>
-              <a:defRPr sz="1350"/>
-            </a:lvl7pPr>
-            <a:lvl8pPr>
-              <a:defRPr sz="1350"/>
-            </a:lvl8pPr>
-            <a:lvl9pPr>
-              <a:defRPr sz="1350"/>
-            </a:lvl9pPr>
-          </a:lstStyle>
-          <a:p>
-            <a:pPr lvl="0"/>
-            <a:r>
-              <a:rPr lang="en-US"/>
+          <a:lstStyle/>
+          <a:p>
+            <a:pPr lvl="0"/>
+            <a:r>
+              <a:rPr lang="en-GB"/>
               <a:t>Click to edit Master text styles</a:t>
             </a:r>
           </a:p>
           <a:p>
             <a:pPr lvl="1"/>
             <a:r>
-              <a:rPr lang="en-US"/>
+              <a:rPr lang="en-GB"/>
               <a:t>Second level</a:t>
             </a:r>
           </a:p>
           <a:p>
             <a:pPr lvl="2"/>
             <a:r>
-              <a:rPr lang="en-US"/>
+              <a:rPr lang="en-GB"/>
               <a:t>Third level</a:t>
             </a:r>
           </a:p>
           <a:p>
             <a:pPr lvl="3"/>
             <a:r>
-              <a:rPr lang="en-US"/>
+              <a:rPr lang="en-GB"/>
               <a:t>Fourth level</a:t>
             </a:r>
           </a:p>
           <a:p>
             <a:pPr lvl="4"/>
             <a:r>
-              <a:rPr lang="en-US"/>
+              <a:rPr lang="en-GB"/>
               <a:t>Fifth level</a:t>
             </a:r>
+            <a:endParaRPr lang="en-GB" dirty="0"/>
           </a:p>
         </p:txBody>
       </p:sp>
@@ -1365,11 +1280,11 @@
           <a:bodyPr/>
           <a:lstStyle/>
           <a:p>
-            <a:fld id="{241EB5C9-1307-BA42-ABA2-0BC069CD8E7F}" type="datetimeFigureOut">
-              <a:rPr lang="en-US" smtClean="0"/>
-              <a:t>1/2/22</a:t>
+            <a:fld id="{846CE7D5-CF57-46EF-B807-FDD0502418D4}" type="datetimeFigureOut">
+              <a:rPr lang="en-GB" smtClean="0"/>
+              <a:t>13/01/2026</a:t>
             </a:fld>
-            <a:endParaRPr lang="en-US"/>
+            <a:endParaRPr lang="en-GB"/>
           </a:p>
         </p:txBody>
       </p:sp>
@@ -1388,7 +1303,10 @@
           <a:bodyPr/>
           <a:lstStyle/>
           <a:p>
-            <a:endParaRPr lang="en-US"/>
+            <a:r>
+              <a:rPr lang="en-GB"/>
+              <a:t>Tâm Anh Oxford Partnership</a:t>
+            </a:r>
           </a:p>
         </p:txBody>
       </p:sp>
@@ -1407,24 +1325,25 @@
           <a:bodyPr/>
           <a:lstStyle/>
           <a:p>
-            <a:fld id="{C5EF2332-01BF-834F-8236-50238282D533}" type="slidenum">
-              <a:rPr lang="en-US" smtClean="0"/>
+            <a:fld id="{330EA680-D336-4FF7-8B7A-9848BB0A1C32}" type="slidenum">
+              <a:rPr lang="en-GB" smtClean="0"/>
               <a:t>‹#›</a:t>
             </a:fld>
-            <a:endParaRPr lang="en-US"/>
+            <a:endParaRPr lang="en-GB"/>
           </a:p>
         </p:txBody>
       </p:sp>
     </p:spTree>
     <p:extLst>
       <p:ext uri="{BB962C8B-B14F-4D97-AF65-F5344CB8AC3E}">
-        <p14:creationId xmlns:p14="http://schemas.microsoft.com/office/powerpoint/2010/main" val="2619886245"/>
+        <p14:creationId xmlns:p14="http://schemas.microsoft.com/office/powerpoint/2010/main" val="1203092039"/>
       </p:ext>
     </p:extLst>
   </p:cSld>
   <p:clrMapOvr>
     <a:masterClrMapping/>
   </p:clrMapOvr>
+  <p:hf hdr="0" dt="0"/>
 </p:sldLayout>
 </file>
 
@@ -1455,36 +1374,38 @@
             <p:ph type="title"/>
           </p:nvPr>
         </p:nvSpPr>
-        <p:spPr/>
-        <p:txBody>
-          <a:bodyPr/>
-          <a:lstStyle>
-            <a:lvl1pPr>
-              <a:defRPr/>
-            </a:lvl1pPr>
-          </a:lstStyle>
-          <a:p>
-            <a:r>
-              <a:rPr lang="en-US"/>
-              <a:t>Click to edit Master title style</a:t>
-            </a:r>
-          </a:p>
-        </p:txBody>
-      </p:sp>
-      <p:sp>
-        <p:nvSpPr>
-          <p:cNvPr id="3" name="Text Placeholder 2"/>
-          <p:cNvSpPr>
-            <a:spLocks noGrp="1"/>
-          </p:cNvSpPr>
-          <p:nvPr>
-            <p:ph type="body" idx="1"/>
-          </p:nvPr>
-        </p:nvSpPr>
         <p:spPr>
           <a:xfrm>
-            <a:off x="457200" y="1151335"/>
-            <a:ext cx="4040188" cy="479822"/>
+            <a:off x="839788" y="365125"/>
+            <a:ext cx="10515600" cy="1325563"/>
+          </a:xfrm>
+        </p:spPr>
+        <p:txBody>
+          <a:bodyPr/>
+          <a:lstStyle/>
+          <a:p>
+            <a:r>
+              <a:rPr lang="en-GB"/>
+              <a:t>Click to edit Master title style</a:t>
+            </a:r>
+            <a:endParaRPr lang="en-GB" dirty="0"/>
+          </a:p>
+        </p:txBody>
+      </p:sp>
+      <p:sp>
+        <p:nvSpPr>
+          <p:cNvPr id="3" name="Text Placeholder 2"/>
+          <p:cNvSpPr>
+            <a:spLocks noGrp="1"/>
+          </p:cNvSpPr>
+          <p:nvPr>
+            <p:ph type="body" idx="1"/>
+          </p:nvPr>
+        </p:nvSpPr>
+        <p:spPr>
+          <a:xfrm>
+            <a:off x="839788" y="1681163"/>
+            <a:ext cx="5157787" cy="823912"/>
           </a:xfrm>
         </p:spPr>
         <p:txBody>
@@ -1492,45 +1413,45 @@
           <a:lstStyle>
             <a:lvl1pPr marL="0" indent="0">
               <a:buNone/>
+              <a:defRPr sz="2400" b="1"/>
+            </a:lvl1pPr>
+            <a:lvl2pPr marL="457200" indent="0">
+              <a:buNone/>
+              <a:defRPr sz="2000" b="1"/>
+            </a:lvl2pPr>
+            <a:lvl3pPr marL="914400" indent="0">
+              <a:buNone/>
               <a:defRPr sz="1800" b="1"/>
-            </a:lvl1pPr>
-            <a:lvl2pPr marL="342900" indent="0">
-              <a:buNone/>
-              <a:defRPr sz="1500" b="1"/>
-            </a:lvl2pPr>
-            <a:lvl3pPr marL="685800" indent="0">
-              <a:buNone/>
-              <a:defRPr sz="1350" b="1"/>
             </a:lvl3pPr>
-            <a:lvl4pPr marL="1028700" indent="0">
-              <a:buNone/>
-              <a:defRPr sz="1200" b="1"/>
+            <a:lvl4pPr marL="1371600" indent="0">
+              <a:buNone/>
+              <a:defRPr sz="1600" b="1"/>
             </a:lvl4pPr>
-            <a:lvl5pPr marL="1371600" indent="0">
-              <a:buNone/>
-              <a:defRPr sz="1200" b="1"/>
+            <a:lvl5pPr marL="1828800" indent="0">
+              <a:buNone/>
+              <a:defRPr sz="1600" b="1"/>
             </a:lvl5pPr>
-            <a:lvl6pPr marL="1714500" indent="0">
-              <a:buNone/>
-              <a:defRPr sz="1200" b="1"/>
+            <a:lvl6pPr marL="2286000" indent="0">
+              <a:buNone/>
+              <a:defRPr sz="1600" b="1"/>
             </a:lvl6pPr>
-            <a:lvl7pPr marL="2057400" indent="0">
-              <a:buNone/>
-              <a:defRPr sz="1200" b="1"/>
+            <a:lvl7pPr marL="2743200" indent="0">
+              <a:buNone/>
+              <a:defRPr sz="1600" b="1"/>
             </a:lvl7pPr>
-            <a:lvl8pPr marL="2400300" indent="0">
-              <a:buNone/>
-              <a:defRPr sz="1200" b="1"/>
+            <a:lvl8pPr marL="3200400" indent="0">
+              <a:buNone/>
+              <a:defRPr sz="1600" b="1"/>
             </a:lvl8pPr>
-            <a:lvl9pPr marL="2743200" indent="0">
-              <a:buNone/>
-              <a:defRPr sz="1200" b="1"/>
+            <a:lvl9pPr marL="3657600" indent="0">
+              <a:buNone/>
+              <a:defRPr sz="1600" b="1"/>
             </a:lvl9pPr>
           </a:lstStyle>
           <a:p>
             <a:pPr lvl="0"/>
             <a:r>
-              <a:rPr lang="en-US"/>
+              <a:rPr lang="en-GB"/>
               <a:t>Click to edit Master text styles</a:t>
             </a:r>
           </a:p>
@@ -1548,75 +1469,48 @@
         </p:nvSpPr>
         <p:spPr>
           <a:xfrm>
-            <a:off x="457200" y="1631156"/>
-            <a:ext cx="4040188" cy="2963466"/>
+            <a:off x="839788" y="2505075"/>
+            <a:ext cx="5157787" cy="3684588"/>
           </a:xfrm>
         </p:spPr>
         <p:txBody>
           <a:bodyPr/>
-          <a:lstStyle>
-            <a:lvl1pPr>
-              <a:defRPr sz="1800"/>
-            </a:lvl1pPr>
-            <a:lvl2pPr>
-              <a:defRPr sz="1500"/>
-            </a:lvl2pPr>
-            <a:lvl3pPr>
-              <a:defRPr sz="1350"/>
-            </a:lvl3pPr>
-            <a:lvl4pPr>
-              <a:defRPr sz="1200"/>
-            </a:lvl4pPr>
-            <a:lvl5pPr>
-              <a:defRPr sz="1200"/>
-            </a:lvl5pPr>
-            <a:lvl6pPr>
-              <a:defRPr sz="1200"/>
-            </a:lvl6pPr>
-            <a:lvl7pPr>
-              <a:defRPr sz="1200"/>
-            </a:lvl7pPr>
-            <a:lvl8pPr>
-              <a:defRPr sz="1200"/>
-            </a:lvl8pPr>
-            <a:lvl9pPr>
-              <a:defRPr sz="1200"/>
-            </a:lvl9pPr>
-          </a:lstStyle>
-          <a:p>
-            <a:pPr lvl="0"/>
-            <a:r>
-              <a:rPr lang="en-US"/>
+          <a:lstStyle/>
+          <a:p>
+            <a:pPr lvl="0"/>
+            <a:r>
+              <a:rPr lang="en-GB"/>
               <a:t>Click to edit Master text styles</a:t>
             </a:r>
           </a:p>
           <a:p>
             <a:pPr lvl="1"/>
             <a:r>
-              <a:rPr lang="en-US"/>
+              <a:rPr lang="en-GB"/>
               <a:t>Second level</a:t>
             </a:r>
           </a:p>
           <a:p>
             <a:pPr lvl="2"/>
             <a:r>
-              <a:rPr lang="en-US"/>
+              <a:rPr lang="en-GB"/>
               <a:t>Third level</a:t>
             </a:r>
           </a:p>
           <a:p>
             <a:pPr lvl="3"/>
             <a:r>
-              <a:rPr lang="en-US"/>
+              <a:rPr lang="en-GB"/>
               <a:t>Fourth level</a:t>
             </a:r>
           </a:p>
           <a:p>
             <a:pPr lvl="4"/>
             <a:r>
-              <a:rPr lang="en-US"/>
+              <a:rPr lang="en-GB"/>
               <a:t>Fifth level</a:t>
             </a:r>
+            <a:endParaRPr lang="en-GB" dirty="0"/>
           </a:p>
         </p:txBody>
       </p:sp>
@@ -1632,8 +1526,8 @@
         </p:nvSpPr>
         <p:spPr>
           <a:xfrm>
-            <a:off x="4645026" y="1151335"/>
-            <a:ext cx="4041775" cy="479822"/>
+            <a:off x="6172200" y="1681163"/>
+            <a:ext cx="5183188" cy="823912"/>
           </a:xfrm>
         </p:spPr>
         <p:txBody>
@@ -1641,45 +1535,45 @@
           <a:lstStyle>
             <a:lvl1pPr marL="0" indent="0">
               <a:buNone/>
+              <a:defRPr sz="2400" b="1"/>
+            </a:lvl1pPr>
+            <a:lvl2pPr marL="457200" indent="0">
+              <a:buNone/>
+              <a:defRPr sz="2000" b="1"/>
+            </a:lvl2pPr>
+            <a:lvl3pPr marL="914400" indent="0">
+              <a:buNone/>
               <a:defRPr sz="1800" b="1"/>
-            </a:lvl1pPr>
-            <a:lvl2pPr marL="342900" indent="0">
-              <a:buNone/>
-              <a:defRPr sz="1500" b="1"/>
-            </a:lvl2pPr>
-            <a:lvl3pPr marL="685800" indent="0">
-              <a:buNone/>
-              <a:defRPr sz="1350" b="1"/>
             </a:lvl3pPr>
-            <a:lvl4pPr marL="1028700" indent="0">
-              <a:buNone/>
-              <a:defRPr sz="1200" b="1"/>
+            <a:lvl4pPr marL="1371600" indent="0">
+              <a:buNone/>
+              <a:defRPr sz="1600" b="1"/>
             </a:lvl4pPr>
-            <a:lvl5pPr marL="1371600" indent="0">
-              <a:buNone/>
-              <a:defRPr sz="1200" b="1"/>
+            <a:lvl5pPr marL="1828800" indent="0">
+              <a:buNone/>
+              <a:defRPr sz="1600" b="1"/>
             </a:lvl5pPr>
-            <a:lvl6pPr marL="1714500" indent="0">
-              <a:buNone/>
-              <a:defRPr sz="1200" b="1"/>
+            <a:lvl6pPr marL="2286000" indent="0">
+              <a:buNone/>
+              <a:defRPr sz="1600" b="1"/>
             </a:lvl6pPr>
-            <a:lvl7pPr marL="2057400" indent="0">
-              <a:buNone/>
-              <a:defRPr sz="1200" b="1"/>
+            <a:lvl7pPr marL="2743200" indent="0">
+              <a:buNone/>
+              <a:defRPr sz="1600" b="1"/>
             </a:lvl7pPr>
-            <a:lvl8pPr marL="2400300" indent="0">
-              <a:buNone/>
-              <a:defRPr sz="1200" b="1"/>
+            <a:lvl8pPr marL="3200400" indent="0">
+              <a:buNone/>
+              <a:defRPr sz="1600" b="1"/>
             </a:lvl8pPr>
-            <a:lvl9pPr marL="2743200" indent="0">
-              <a:buNone/>
-              <a:defRPr sz="1200" b="1"/>
+            <a:lvl9pPr marL="3657600" indent="0">
+              <a:buNone/>
+              <a:defRPr sz="1600" b="1"/>
             </a:lvl9pPr>
           </a:lstStyle>
           <a:p>
             <a:pPr lvl="0"/>
             <a:r>
-              <a:rPr lang="en-US"/>
+              <a:rPr lang="en-GB"/>
               <a:t>Click to edit Master text styles</a:t>
             </a:r>
           </a:p>
@@ -1697,75 +1591,48 @@
         </p:nvSpPr>
         <p:spPr>
           <a:xfrm>
-            <a:off x="4645026" y="1631156"/>
-            <a:ext cx="4041775" cy="2963466"/>
+            <a:off x="6172200" y="2505075"/>
+            <a:ext cx="5183188" cy="3684588"/>
           </a:xfrm>
         </p:spPr>
         <p:txBody>
           <a:bodyPr/>
-          <a:lstStyle>
-            <a:lvl1pPr>
-              <a:defRPr sz="1800"/>
-            </a:lvl1pPr>
-            <a:lvl2pPr>
-              <a:defRPr sz="1500"/>
-            </a:lvl2pPr>
-            <a:lvl3pPr>
-              <a:defRPr sz="1350"/>
-            </a:lvl3pPr>
-            <a:lvl4pPr>
-              <a:defRPr sz="1200"/>
-            </a:lvl4pPr>
-            <a:lvl5pPr>
-              <a:defRPr sz="1200"/>
-            </a:lvl5pPr>
-            <a:lvl6pPr>
-              <a:defRPr sz="1200"/>
-            </a:lvl6pPr>
-            <a:lvl7pPr>
-              <a:defRPr sz="1200"/>
-            </a:lvl7pPr>
-            <a:lvl8pPr>
-              <a:defRPr sz="1200"/>
-            </a:lvl8pPr>
-            <a:lvl9pPr>
-              <a:defRPr sz="1200"/>
-            </a:lvl9pPr>
-          </a:lstStyle>
-          <a:p>
-            <a:pPr lvl="0"/>
-            <a:r>
-              <a:rPr lang="en-US"/>
+          <a:lstStyle/>
+          <a:p>
+            <a:pPr lvl="0"/>
+            <a:r>
+              <a:rPr lang="en-GB"/>
               <a:t>Click to edit Master text styles</a:t>
             </a:r>
           </a:p>
           <a:p>
             <a:pPr lvl="1"/>
             <a:r>
-              <a:rPr lang="en-US"/>
+              <a:rPr lang="en-GB"/>
               <a:t>Second level</a:t>
             </a:r>
           </a:p>
           <a:p>
             <a:pPr lvl="2"/>
             <a:r>
-              <a:rPr lang="en-US"/>
+              <a:rPr lang="en-GB"/>
               <a:t>Third level</a:t>
             </a:r>
           </a:p>
           <a:p>
             <a:pPr lvl="3"/>
             <a:r>
-              <a:rPr lang="en-US"/>
+              <a:rPr lang="en-GB"/>
               <a:t>Fourth level</a:t>
             </a:r>
           </a:p>
           <a:p>
             <a:pPr lvl="4"/>
             <a:r>
-              <a:rPr lang="en-US"/>
+              <a:rPr lang="en-GB"/>
               <a:t>Fifth level</a:t>
             </a:r>
+            <a:endParaRPr lang="en-GB" dirty="0"/>
           </a:p>
         </p:txBody>
       </p:sp>
@@ -1784,11 +1651,11 @@
           <a:bodyPr/>
           <a:lstStyle/>
           <a:p>
-            <a:fld id="{241EB5C9-1307-BA42-ABA2-0BC069CD8E7F}" type="datetimeFigureOut">
-              <a:rPr lang="en-US" smtClean="0"/>
-              <a:t>1/2/22</a:t>
+            <a:fld id="{846CE7D5-CF57-46EF-B807-FDD0502418D4}" type="datetimeFigureOut">
+              <a:rPr lang="en-GB" smtClean="0"/>
+              <a:t>13/01/2026</a:t>
             </a:fld>
-            <a:endParaRPr lang="en-US"/>
+            <a:endParaRPr lang="en-GB"/>
           </a:p>
         </p:txBody>
       </p:sp>
@@ -1807,7 +1674,10 @@
           <a:bodyPr/>
           <a:lstStyle/>
           <a:p>
-            <a:endParaRPr lang="en-US"/>
+            <a:r>
+              <a:rPr lang="en-GB"/>
+              <a:t>Tâm Anh Oxford Partnership</a:t>
+            </a:r>
           </a:p>
         </p:txBody>
       </p:sp>
@@ -1826,24 +1696,25 @@
           <a:bodyPr/>
           <a:lstStyle/>
           <a:p>
-            <a:fld id="{C5EF2332-01BF-834F-8236-50238282D533}" type="slidenum">
-              <a:rPr lang="en-US" smtClean="0"/>
+            <a:fld id="{330EA680-D336-4FF7-8B7A-9848BB0A1C32}" type="slidenum">
+              <a:rPr lang="en-GB" smtClean="0"/>
               <a:t>‹#›</a:t>
             </a:fld>
-            <a:endParaRPr lang="en-US"/>
+            <a:endParaRPr lang="en-GB"/>
           </a:p>
         </p:txBody>
       </p:sp>
     </p:spTree>
     <p:extLst>
       <p:ext uri="{BB962C8B-B14F-4D97-AF65-F5344CB8AC3E}">
-        <p14:creationId xmlns:p14="http://schemas.microsoft.com/office/powerpoint/2010/main" val="2535793967"/>
+        <p14:creationId xmlns:p14="http://schemas.microsoft.com/office/powerpoint/2010/main" val="3733172339"/>
       </p:ext>
     </p:extLst>
   </p:cSld>
   <p:clrMapOvr>
     <a:masterClrMapping/>
   </p:clrMapOvr>
+  <p:hf hdr="0" dt="0"/>
 </p:sldLayout>
 </file>
 
@@ -1880,9 +1751,10 @@
           <a:lstStyle/>
           <a:p>
             <a:r>
-              <a:rPr lang="en-US"/>
+              <a:rPr lang="en-GB"/>
               <a:t>Click to edit Master title style</a:t>
             </a:r>
+            <a:endParaRPr lang="en-GB" dirty="0"/>
           </a:p>
         </p:txBody>
       </p:sp>
@@ -1901,11 +1773,11 @@
           <a:bodyPr/>
           <a:lstStyle/>
           <a:p>
-            <a:fld id="{241EB5C9-1307-BA42-ABA2-0BC069CD8E7F}" type="datetimeFigureOut">
-              <a:rPr lang="en-US" smtClean="0"/>
-              <a:t>1/2/22</a:t>
+            <a:fld id="{846CE7D5-CF57-46EF-B807-FDD0502418D4}" type="datetimeFigureOut">
+              <a:rPr lang="en-GB" smtClean="0"/>
+              <a:t>13/01/2026</a:t>
             </a:fld>
-            <a:endParaRPr lang="en-US"/>
+            <a:endParaRPr lang="en-GB"/>
           </a:p>
         </p:txBody>
       </p:sp>
@@ -1924,7 +1796,10 @@
           <a:bodyPr/>
           <a:lstStyle/>
           <a:p>
-            <a:endParaRPr lang="en-US"/>
+            <a:r>
+              <a:rPr lang="en-GB"/>
+              <a:t>Tâm Anh Oxford Partnership</a:t>
+            </a:r>
           </a:p>
         </p:txBody>
       </p:sp>
@@ -1943,24 +1818,25 @@
           <a:bodyPr/>
           <a:lstStyle/>
           <a:p>
-            <a:fld id="{C5EF2332-01BF-834F-8236-50238282D533}" type="slidenum">
-              <a:rPr lang="en-US" smtClean="0"/>
+            <a:fld id="{330EA680-D336-4FF7-8B7A-9848BB0A1C32}" type="slidenum">
+              <a:rPr lang="en-GB" smtClean="0"/>
               <a:t>‹#›</a:t>
             </a:fld>
-            <a:endParaRPr lang="en-US"/>
+            <a:endParaRPr lang="en-GB"/>
           </a:p>
         </p:txBody>
       </p:sp>
     </p:spTree>
     <p:extLst>
       <p:ext uri="{BB962C8B-B14F-4D97-AF65-F5344CB8AC3E}">
-        <p14:creationId xmlns:p14="http://schemas.microsoft.com/office/powerpoint/2010/main" val="3472721253"/>
+        <p14:creationId xmlns:p14="http://schemas.microsoft.com/office/powerpoint/2010/main" val="3210312558"/>
       </p:ext>
     </p:extLst>
   </p:cSld>
   <p:clrMapOvr>
     <a:masterClrMapping/>
   </p:clrMapOvr>
+  <p:hf hdr="0" dt="0"/>
 </p:sldLayout>
 </file>
 
@@ -1996,11 +1872,11 @@
           <a:bodyPr/>
           <a:lstStyle/>
           <a:p>
-            <a:fld id="{241EB5C9-1307-BA42-ABA2-0BC069CD8E7F}" type="datetimeFigureOut">
-              <a:rPr lang="en-US" smtClean="0"/>
-              <a:t>1/2/22</a:t>
+            <a:fld id="{846CE7D5-CF57-46EF-B807-FDD0502418D4}" type="datetimeFigureOut">
+              <a:rPr lang="en-GB" smtClean="0"/>
+              <a:t>13/01/2026</a:t>
             </a:fld>
-            <a:endParaRPr lang="en-US"/>
+            <a:endParaRPr lang="en-GB"/>
           </a:p>
         </p:txBody>
       </p:sp>
@@ -2019,7 +1895,10 @@
           <a:bodyPr/>
           <a:lstStyle/>
           <a:p>
-            <a:endParaRPr lang="en-US"/>
+            <a:r>
+              <a:rPr lang="en-GB"/>
+              <a:t>Tâm Anh Oxford Partnership</a:t>
+            </a:r>
           </a:p>
         </p:txBody>
       </p:sp>
@@ -2038,24 +1917,25 @@
           <a:bodyPr/>
           <a:lstStyle/>
           <a:p>
-            <a:fld id="{C5EF2332-01BF-834F-8236-50238282D533}" type="slidenum">
-              <a:rPr lang="en-US" smtClean="0"/>
+            <a:fld id="{330EA680-D336-4FF7-8B7A-9848BB0A1C32}" type="slidenum">
+              <a:rPr lang="en-GB" smtClean="0"/>
               <a:t>‹#›</a:t>
             </a:fld>
-            <a:endParaRPr lang="en-US"/>
+            <a:endParaRPr lang="en-GB"/>
           </a:p>
         </p:txBody>
       </p:sp>
     </p:spTree>
     <p:extLst>
       <p:ext uri="{BB962C8B-B14F-4D97-AF65-F5344CB8AC3E}">
-        <p14:creationId xmlns:p14="http://schemas.microsoft.com/office/powerpoint/2010/main" val="2130901097"/>
+        <p14:creationId xmlns:p14="http://schemas.microsoft.com/office/powerpoint/2010/main" val="3146388984"/>
       </p:ext>
     </p:extLst>
   </p:cSld>
   <p:clrMapOvr>
     <a:masterClrMapping/>
   </p:clrMapOvr>
+  <p:hf hdr="0" dt="0"/>
 </p:sldLayout>
 </file>
 
@@ -2088,22 +1968,23 @@
         </p:nvSpPr>
         <p:spPr>
           <a:xfrm>
-            <a:off x="457201" y="204787"/>
-            <a:ext cx="3008313" cy="871538"/>
+            <a:off x="839788" y="457200"/>
+            <a:ext cx="3932237" cy="1600200"/>
           </a:xfrm>
         </p:spPr>
         <p:txBody>
           <a:bodyPr anchor="b"/>
           <a:lstStyle>
-            <a:lvl1pPr algn="l">
-              <a:defRPr sz="1500" b="1"/>
+            <a:lvl1pPr>
+              <a:defRPr sz="3200"/>
             </a:lvl1pPr>
           </a:lstStyle>
           <a:p>
             <a:r>
-              <a:rPr lang="en-US"/>
+              <a:rPr lang="en-GB"/>
               <a:t>Click to edit Master title style</a:t>
             </a:r>
+            <a:endParaRPr lang="en-GB" dirty="0"/>
           </a:p>
         </p:txBody>
       </p:sp>
@@ -2119,75 +2000,76 @@
         </p:nvSpPr>
         <p:spPr>
           <a:xfrm>
-            <a:off x="3575050" y="204788"/>
-            <a:ext cx="5111750" cy="4389835"/>
+            <a:off x="5183188" y="987425"/>
+            <a:ext cx="6172200" cy="4873625"/>
           </a:xfrm>
         </p:spPr>
         <p:txBody>
           <a:bodyPr/>
           <a:lstStyle>
             <a:lvl1pPr>
-              <a:defRPr sz="2400"/>
+              <a:defRPr sz="3200"/>
             </a:lvl1pPr>
             <a:lvl2pPr>
-              <a:defRPr sz="2100"/>
+              <a:defRPr sz="2800"/>
             </a:lvl2pPr>
             <a:lvl3pPr>
-              <a:defRPr sz="1800"/>
+              <a:defRPr sz="2400"/>
             </a:lvl3pPr>
             <a:lvl4pPr>
-              <a:defRPr sz="1500"/>
+              <a:defRPr sz="2000"/>
             </a:lvl4pPr>
             <a:lvl5pPr>
-              <a:defRPr sz="1500"/>
+              <a:defRPr sz="2000"/>
             </a:lvl5pPr>
             <a:lvl6pPr>
-              <a:defRPr sz="1500"/>
+              <a:defRPr sz="2000"/>
             </a:lvl6pPr>
             <a:lvl7pPr>
-              <a:defRPr sz="1500"/>
+              <a:defRPr sz="2000"/>
             </a:lvl7pPr>
             <a:lvl8pPr>
-              <a:defRPr sz="1500"/>
+              <a:defRPr sz="2000"/>
             </a:lvl8pPr>
             <a:lvl9pPr>
-              <a:defRPr sz="1500"/>
+              <a:defRPr sz="2000"/>
             </a:lvl9pPr>
           </a:lstStyle>
           <a:p>
             <a:pPr lvl="0"/>
             <a:r>
-              <a:rPr lang="en-US"/>
+              <a:rPr lang="en-GB"/>
               <a:t>Click to edit Master text styles</a:t>
             </a:r>
           </a:p>
           <a:p>
             <a:pPr lvl="1"/>
             <a:r>
-              <a:rPr lang="en-US"/>
+              <a:rPr lang="en-GB"/>
               <a:t>Second level</a:t>
             </a:r>
           </a:p>
           <a:p>
             <a:pPr lvl="2"/>
             <a:r>
-              <a:rPr lang="en-US"/>
+              <a:rPr lang="en-GB"/>
               <a:t>Third level</a:t>
             </a:r>
           </a:p>
           <a:p>
             <a:pPr lvl="3"/>
             <a:r>
-              <a:rPr lang="en-US"/>
+              <a:rPr lang="en-GB"/>
               <a:t>Fourth level</a:t>
             </a:r>
           </a:p>
           <a:p>
             <a:pPr lvl="4"/>
             <a:r>
-              <a:rPr lang="en-US"/>
+              <a:rPr lang="en-GB"/>
               <a:t>Fifth level</a:t>
             </a:r>
+            <a:endParaRPr lang="en-GB" dirty="0"/>
           </a:p>
         </p:txBody>
       </p:sp>
@@ -2203,8 +2085,8 @@
         </p:nvSpPr>
         <p:spPr>
           <a:xfrm>
-            <a:off x="457201" y="1076326"/>
-            <a:ext cx="3008313" cy="3518297"/>
+            <a:off x="839788" y="2057400"/>
+            <a:ext cx="3932237" cy="3811588"/>
           </a:xfrm>
         </p:spPr>
         <p:txBody>
@@ -2212,45 +2094,45 @@
           <a:lstStyle>
             <a:lvl1pPr marL="0" indent="0">
               <a:buNone/>
-              <a:defRPr sz="1050"/>
+              <a:defRPr sz="1600"/>
             </a:lvl1pPr>
-            <a:lvl2pPr marL="342900" indent="0">
-              <a:buNone/>
-              <a:defRPr sz="900"/>
+            <a:lvl2pPr marL="457200" indent="0">
+              <a:buNone/>
+              <a:defRPr sz="1400"/>
             </a:lvl2pPr>
-            <a:lvl3pPr marL="685800" indent="0">
-              <a:buNone/>
-              <a:defRPr sz="750"/>
+            <a:lvl3pPr marL="914400" indent="0">
+              <a:buNone/>
+              <a:defRPr sz="1200"/>
             </a:lvl3pPr>
-            <a:lvl4pPr marL="1028700" indent="0">
-              <a:buNone/>
-              <a:defRPr sz="675"/>
+            <a:lvl4pPr marL="1371600" indent="0">
+              <a:buNone/>
+              <a:defRPr sz="1000"/>
             </a:lvl4pPr>
-            <a:lvl5pPr marL="1371600" indent="0">
-              <a:buNone/>
-              <a:defRPr sz="675"/>
+            <a:lvl5pPr marL="1828800" indent="0">
+              <a:buNone/>
+              <a:defRPr sz="1000"/>
             </a:lvl5pPr>
-            <a:lvl6pPr marL="1714500" indent="0">
-              <a:buNone/>
-              <a:defRPr sz="675"/>
+            <a:lvl6pPr marL="2286000" indent="0">
+              <a:buNone/>
+              <a:defRPr sz="1000"/>
             </a:lvl6pPr>
-            <a:lvl7pPr marL="2057400" indent="0">
-              <a:buNone/>
-              <a:defRPr sz="675"/>
+            <a:lvl7pPr marL="2743200" indent="0">
+              <a:buNone/>
+              <a:defRPr sz="1000"/>
             </a:lvl7pPr>
-            <a:lvl8pPr marL="2400300" indent="0">
-              <a:buNone/>
-              <a:defRPr sz="675"/>
+            <a:lvl8pPr marL="3200400" indent="0">
+              <a:buNone/>
+              <a:defRPr sz="1000"/>
             </a:lvl8pPr>
-            <a:lvl9pPr marL="2743200" indent="0">
-              <a:buNone/>
-              <a:defRPr sz="675"/>
+            <a:lvl9pPr marL="3657600" indent="0">
+              <a:buNone/>
+              <a:defRPr sz="1000"/>
             </a:lvl9pPr>
           </a:lstStyle>
           <a:p>
             <a:pPr lvl="0"/>
             <a:r>
-              <a:rPr lang="en-US"/>
+              <a:rPr lang="en-GB"/>
               <a:t>Click to edit Master text styles</a:t>
             </a:r>
           </a:p>
@@ -2271,11 +2153,11 @@
           <a:bodyPr/>
           <a:lstStyle/>
           <a:p>
-            <a:fld id="{241EB5C9-1307-BA42-ABA2-0BC069CD8E7F}" type="datetimeFigureOut">
-              <a:rPr lang="en-US" smtClean="0"/>
-              <a:t>1/2/22</a:t>
+            <a:fld id="{846CE7D5-CF57-46EF-B807-FDD0502418D4}" type="datetimeFigureOut">
+              <a:rPr lang="en-GB" smtClean="0"/>
+              <a:t>13/01/2026</a:t>
             </a:fld>
-            <a:endParaRPr lang="en-US"/>
+            <a:endParaRPr lang="en-GB"/>
           </a:p>
         </p:txBody>
       </p:sp>
@@ -2294,7 +2176,10 @@
           <a:bodyPr/>
           <a:lstStyle/>
           <a:p>
-            <a:endParaRPr lang="en-US"/>
+            <a:r>
+              <a:rPr lang="en-GB"/>
+              <a:t>Tâm Anh Oxford Partnership</a:t>
+            </a:r>
           </a:p>
         </p:txBody>
       </p:sp>
@@ -2313,24 +2198,25 @@
           <a:bodyPr/>
           <a:lstStyle/>
           <a:p>
-            <a:fld id="{C5EF2332-01BF-834F-8236-50238282D533}" type="slidenum">
-              <a:rPr lang="en-US" smtClean="0"/>
+            <a:fld id="{330EA680-D336-4FF7-8B7A-9848BB0A1C32}" type="slidenum">
+              <a:rPr lang="en-GB" smtClean="0"/>
               <a:t>‹#›</a:t>
             </a:fld>
-            <a:endParaRPr lang="en-US"/>
+            <a:endParaRPr lang="en-GB"/>
           </a:p>
         </p:txBody>
       </p:sp>
     </p:spTree>
     <p:extLst>
       <p:ext uri="{BB962C8B-B14F-4D97-AF65-F5344CB8AC3E}">
-        <p14:creationId xmlns:p14="http://schemas.microsoft.com/office/powerpoint/2010/main" val="3540895647"/>
+        <p14:creationId xmlns:p14="http://schemas.microsoft.com/office/powerpoint/2010/main" val="3171841454"/>
       </p:ext>
     </p:extLst>
   </p:cSld>
   <p:clrMapOvr>
     <a:masterClrMapping/>
   </p:clrMapOvr>
+  <p:hf hdr="0" dt="0"/>
 </p:sldLayout>
 </file>
 
@@ -2363,22 +2249,23 @@
         </p:nvSpPr>
         <p:spPr>
           <a:xfrm>
-            <a:off x="1792288" y="3600450"/>
-            <a:ext cx="5486400" cy="425054"/>
+            <a:off x="839788" y="457200"/>
+            <a:ext cx="3932237" cy="1600200"/>
           </a:xfrm>
         </p:spPr>
         <p:txBody>
           <a:bodyPr anchor="b"/>
           <a:lstStyle>
-            <a:lvl1pPr algn="l">
-              <a:defRPr sz="1500" b="1"/>
+            <a:lvl1pPr>
+              <a:defRPr sz="3200"/>
             </a:lvl1pPr>
           </a:lstStyle>
           <a:p>
             <a:r>
-              <a:rPr lang="en-US"/>
+              <a:rPr lang="en-GB"/>
               <a:t>Click to edit Master title style</a:t>
             </a:r>
+            <a:endParaRPr lang="en-GB" dirty="0"/>
           </a:p>
         </p:txBody>
       </p:sp>
@@ -2386,7 +2273,7 @@
         <p:nvSpPr>
           <p:cNvPr id="3" name="Picture Placeholder 2"/>
           <p:cNvSpPr>
-            <a:spLocks noGrp="1"/>
+            <a:spLocks noGrp="1" noChangeAspect="1"/>
           </p:cNvSpPr>
           <p:nvPr>
             <p:ph type="pic" idx="1"/>
@@ -2394,52 +2281,56 @@
         </p:nvSpPr>
         <p:spPr>
           <a:xfrm>
-            <a:off x="1792288" y="459581"/>
-            <a:ext cx="5486400" cy="3086100"/>
+            <a:off x="5183188" y="987425"/>
+            <a:ext cx="6172200" cy="4873625"/>
           </a:xfrm>
         </p:spPr>
         <p:txBody>
-          <a:bodyPr/>
+          <a:bodyPr anchor="t"/>
           <a:lstStyle>
             <a:lvl1pPr marL="0" indent="0">
               <a:buNone/>
+              <a:defRPr sz="3200"/>
+            </a:lvl1pPr>
+            <a:lvl2pPr marL="457200" indent="0">
+              <a:buNone/>
+              <a:defRPr sz="2800"/>
+            </a:lvl2pPr>
+            <a:lvl3pPr marL="914400" indent="0">
+              <a:buNone/>
               <a:defRPr sz="2400"/>
-            </a:lvl1pPr>
-            <a:lvl2pPr marL="342900" indent="0">
-              <a:buNone/>
-              <a:defRPr sz="2100"/>
-            </a:lvl2pPr>
-            <a:lvl3pPr marL="685800" indent="0">
-              <a:buNone/>
-              <a:defRPr sz="1800"/>
             </a:lvl3pPr>
-            <a:lvl4pPr marL="1028700" indent="0">
-              <a:buNone/>
-              <a:defRPr sz="1500"/>
+            <a:lvl4pPr marL="1371600" indent="0">
+              <a:buNone/>
+              <a:defRPr sz="2000"/>
             </a:lvl4pPr>
-            <a:lvl5pPr marL="1371600" indent="0">
-              <a:buNone/>
-              <a:defRPr sz="1500"/>
+            <a:lvl5pPr marL="1828800" indent="0">
+              <a:buNone/>
+              <a:defRPr sz="2000"/>
             </a:lvl5pPr>
-            <a:lvl6pPr marL="1714500" indent="0">
-              <a:buNone/>
-              <a:defRPr sz="1500"/>
+            <a:lvl6pPr marL="2286000" indent="0">
+              <a:buNone/>
+              <a:defRPr sz="2000"/>
             </a:lvl6pPr>
-            <a:lvl7pPr marL="2057400" indent="0">
-              <a:buNone/>
-              <a:defRPr sz="1500"/>
+            <a:lvl7pPr marL="2743200" indent="0">
+              <a:buNone/>
+              <a:defRPr sz="2000"/>
             </a:lvl7pPr>
-            <a:lvl8pPr marL="2400300" indent="0">
-              <a:buNone/>
-              <a:defRPr sz="1500"/>
+            <a:lvl8pPr marL="3200400" indent="0">
+              <a:buNone/>
+              <a:defRPr sz="2000"/>
             </a:lvl8pPr>
-            <a:lvl9pPr marL="2743200" indent="0">
-              <a:buNone/>
-              <a:defRPr sz="1500"/>
+            <a:lvl9pPr marL="3657600" indent="0">
+              <a:buNone/>
+              <a:defRPr sz="2000"/>
             </a:lvl9pPr>
           </a:lstStyle>
           <a:p>
-            <a:endParaRPr lang="en-US"/>
+            <a:r>
+              <a:rPr lang="en-GB"/>
+              <a:t>Click icon to add picture</a:t>
+            </a:r>
+            <a:endParaRPr lang="en-GB" dirty="0"/>
           </a:p>
         </p:txBody>
       </p:sp>
@@ -2455,8 +2346,8 @@
         </p:nvSpPr>
         <p:spPr>
           <a:xfrm>
-            <a:off x="1792288" y="4025503"/>
-            <a:ext cx="5486400" cy="603647"/>
+            <a:off x="839788" y="2057400"/>
+            <a:ext cx="3932237" cy="3811588"/>
           </a:xfrm>
         </p:spPr>
         <p:txBody>
@@ -2464,45 +2355,45 @@
           <a:lstStyle>
             <a:lvl1pPr marL="0" indent="0">
               <a:buNone/>
-              <a:defRPr sz="1050"/>
+              <a:defRPr sz="1600"/>
             </a:lvl1pPr>
-            <a:lvl2pPr marL="342900" indent="0">
-              <a:buNone/>
-              <a:defRPr sz="900"/>
+            <a:lvl2pPr marL="457200" indent="0">
+              <a:buNone/>
+              <a:defRPr sz="1400"/>
             </a:lvl2pPr>
-            <a:lvl3pPr marL="685800" indent="0">
-              <a:buNone/>
-              <a:defRPr sz="750"/>
+            <a:lvl3pPr marL="914400" indent="0">
+              <a:buNone/>
+              <a:defRPr sz="1200"/>
             </a:lvl3pPr>
-            <a:lvl4pPr marL="1028700" indent="0">
-              <a:buNone/>
-              <a:defRPr sz="675"/>
+            <a:lvl4pPr marL="1371600" indent="0">
+              <a:buNone/>
+              <a:defRPr sz="1000"/>
             </a:lvl4pPr>
-            <a:lvl5pPr marL="1371600" indent="0">
-              <a:buNone/>
-              <a:defRPr sz="675"/>
+            <a:lvl5pPr marL="1828800" indent="0">
+              <a:buNone/>
+              <a:defRPr sz="1000"/>
             </a:lvl5pPr>
-            <a:lvl6pPr marL="1714500" indent="0">
-              <a:buNone/>
-              <a:defRPr sz="675"/>
+            <a:lvl6pPr marL="2286000" indent="0">
+              <a:buNone/>
+              <a:defRPr sz="1000"/>
             </a:lvl6pPr>
-            <a:lvl7pPr marL="2057400" indent="0">
-              <a:buNone/>
-              <a:defRPr sz="675"/>
+            <a:lvl7pPr marL="2743200" indent="0">
+              <a:buNone/>
+              <a:defRPr sz="1000"/>
             </a:lvl7pPr>
-            <a:lvl8pPr marL="2400300" indent="0">
-              <a:buNone/>
-              <a:defRPr sz="675"/>
+            <a:lvl8pPr marL="3200400" indent="0">
+              <a:buNone/>
+              <a:defRPr sz="1000"/>
             </a:lvl8pPr>
-            <a:lvl9pPr marL="2743200" indent="0">
-              <a:buNone/>
-              <a:defRPr sz="675"/>
+            <a:lvl9pPr marL="3657600" indent="0">
+              <a:buNone/>
+              <a:defRPr sz="1000"/>
             </a:lvl9pPr>
           </a:lstStyle>
           <a:p>
             <a:pPr lvl="0"/>
             <a:r>
-              <a:rPr lang="en-US"/>
+              <a:rPr lang="en-GB"/>
               <a:t>Click to edit Master text styles</a:t>
             </a:r>
           </a:p>
@@ -2523,11 +2414,11 @@
           <a:bodyPr/>
           <a:lstStyle/>
           <a:p>
-            <a:fld id="{241EB5C9-1307-BA42-ABA2-0BC069CD8E7F}" type="datetimeFigureOut">
-              <a:rPr lang="en-US" smtClean="0"/>
-              <a:t>1/2/22</a:t>
+            <a:fld id="{846CE7D5-CF57-46EF-B807-FDD0502418D4}" type="datetimeFigureOut">
+              <a:rPr lang="en-GB" smtClean="0"/>
+              <a:t>13/01/2026</a:t>
             </a:fld>
-            <a:endParaRPr lang="en-US"/>
+            <a:endParaRPr lang="en-GB"/>
           </a:p>
         </p:txBody>
       </p:sp>
@@ -2546,7 +2437,10 @@
           <a:bodyPr/>
           <a:lstStyle/>
           <a:p>
-            <a:endParaRPr lang="en-US"/>
+            <a:r>
+              <a:rPr lang="en-GB"/>
+              <a:t>Tâm Anh Oxford Partnership</a:t>
+            </a:r>
           </a:p>
         </p:txBody>
       </p:sp>
@@ -2565,24 +2459,25 @@
           <a:bodyPr/>
           <a:lstStyle/>
           <a:p>
-            <a:fld id="{C5EF2332-01BF-834F-8236-50238282D533}" type="slidenum">
-              <a:rPr lang="en-US" smtClean="0"/>
+            <a:fld id="{330EA680-D336-4FF7-8B7A-9848BB0A1C32}" type="slidenum">
+              <a:rPr lang="en-GB" smtClean="0"/>
               <a:t>‹#›</a:t>
             </a:fld>
-            <a:endParaRPr lang="en-US"/>
+            <a:endParaRPr lang="en-GB"/>
           </a:p>
         </p:txBody>
       </p:sp>
     </p:spTree>
     <p:extLst>
       <p:ext uri="{BB962C8B-B14F-4D97-AF65-F5344CB8AC3E}">
-        <p14:creationId xmlns:p14="http://schemas.microsoft.com/office/powerpoint/2010/main" val="3566899855"/>
+        <p14:creationId xmlns:p14="http://schemas.microsoft.com/office/powerpoint/2010/main" val="1718958274"/>
       </p:ext>
     </p:extLst>
   </p:cSld>
   <p:clrMapOvr>
     <a:masterClrMapping/>
   </p:clrMapOvr>
+  <p:hf hdr="0" dt="0"/>
 </p:sldLayout>
 </file>
 
@@ -2620,8 +2515,8 @@
         </p:nvSpPr>
         <p:spPr>
           <a:xfrm>
-            <a:off x="457200" y="205979"/>
-            <a:ext cx="8229600" cy="857250"/>
+            <a:off x="838200" y="365125"/>
+            <a:ext cx="10515600" cy="1325563"/>
           </a:xfrm>
           <a:prstGeom prst="rect">
             <a:avLst/>
@@ -2634,9 +2529,10 @@
           <a:lstStyle/>
           <a:p>
             <a:r>
-              <a:rPr lang="en-US"/>
+              <a:rPr lang="en-GB"/>
               <a:t>Click to edit Master title style</a:t>
             </a:r>
+            <a:endParaRPr dirty="0" lang="en-GB"/>
           </a:p>
         </p:txBody>
       </p:sp>
@@ -2652,8 +2548,8 @@
         </p:nvSpPr>
         <p:spPr>
           <a:xfrm>
-            <a:off x="457200" y="1200151"/>
-            <a:ext cx="8229600" cy="3394472"/>
+            <a:off x="838200" y="1825625"/>
+            <a:ext cx="10515600" cy="4351338"/>
           </a:xfrm>
           <a:prstGeom prst="rect">
             <a:avLst/>
@@ -2667,37 +2563,38 @@
           <a:p>
             <a:pPr lvl="0"/>
             <a:r>
-              <a:rPr lang="en-US"/>
+              <a:rPr lang="en-GB"/>
               <a:t>Click to edit Master text styles</a:t>
             </a:r>
           </a:p>
           <a:p>
             <a:pPr lvl="1"/>
             <a:r>
-              <a:rPr lang="en-US"/>
+              <a:rPr lang="en-GB"/>
               <a:t>Second level</a:t>
             </a:r>
           </a:p>
           <a:p>
             <a:pPr lvl="2"/>
             <a:r>
-              <a:rPr lang="en-US"/>
+              <a:rPr lang="en-GB"/>
               <a:t>Third level</a:t>
             </a:r>
           </a:p>
           <a:p>
             <a:pPr lvl="3"/>
             <a:r>
-              <a:rPr lang="en-US"/>
+              <a:rPr lang="en-GB"/>
               <a:t>Fourth level</a:t>
             </a:r>
           </a:p>
           <a:p>
             <a:pPr lvl="4"/>
             <a:r>
-              <a:rPr lang="en-US"/>
+              <a:rPr lang="en-GB"/>
               <a:t>Fifth level</a:t>
             </a:r>
+            <a:endParaRPr dirty="0" lang="en-GB"/>
           </a:p>
         </p:txBody>
       </p:sp>
@@ -2713,8 +2610,8 @@
         </p:nvSpPr>
         <p:spPr>
           <a:xfrm>
-            <a:off x="457200" y="4767263"/>
-            <a:ext cx="2133600" cy="273844"/>
+            <a:off x="838200" y="6356350"/>
+            <a:ext cx="2743200" cy="365125"/>
           </a:xfrm>
           <a:prstGeom prst="rect">
             <a:avLst/>
@@ -2724,21 +2621,21 @@
           <a:bodyPr anchor="ctr" bIns="45720" lIns="91440" rIns="91440" rtlCol="0" tIns="45720" vert="horz"/>
           <a:lstStyle>
             <a:lvl1pPr algn="l">
-              <a:defRPr sz="900">
+              <a:defRPr sz="1200">
                 <a:solidFill>
                   <a:schemeClr val="tx1">
-                    <a:tint val="75000"/>
+                    <a:tint val="82000"/>
                   </a:schemeClr>
                 </a:solidFill>
               </a:defRPr>
             </a:lvl1pPr>
           </a:lstStyle>
           <a:p>
-            <a:fld id="{241EB5C9-1307-BA42-ABA2-0BC069CD8E7F}" type="datetimeFigureOut">
-              <a:rPr lang="en-US" smtClean="0"/>
-              <a:t>1/2/22</a:t>
+            <a:fld id="{846CE7D5-CF57-46EF-B807-FDD0502418D4}" type="datetimeFigureOut">
+              <a:rPr lang="en-GB" smtClean="0"/>
+              <a:t>13/01/2026</a:t>
             </a:fld>
-            <a:endParaRPr lang="en-US"/>
+            <a:endParaRPr lang="en-GB"/>
           </a:p>
         </p:txBody>
       </p:sp>
@@ -2754,8 +2651,8 @@
         </p:nvSpPr>
         <p:spPr>
           <a:xfrm>
-            <a:off x="3124200" y="4767263"/>
-            <a:ext cx="2895600" cy="273844"/>
+            <a:off x="4038600" y="6356350"/>
+            <a:ext cx="4114800" cy="365125"/>
           </a:xfrm>
           <a:prstGeom prst="rect">
             <a:avLst/>
@@ -2765,17 +2662,20 @@
           <a:bodyPr anchor="ctr" bIns="45720" lIns="91440" rIns="91440" rtlCol="0" tIns="45720" vert="horz"/>
           <a:lstStyle>
             <a:lvl1pPr algn="ctr">
-              <a:defRPr sz="900">
+              <a:defRPr sz="1200">
                 <a:solidFill>
                   <a:schemeClr val="tx1">
-                    <a:tint val="75000"/>
+                    <a:tint val="82000"/>
                   </a:schemeClr>
                 </a:solidFill>
               </a:defRPr>
             </a:lvl1pPr>
           </a:lstStyle>
           <a:p>
-            <a:endParaRPr lang="en-US"/>
+            <a:r>
+              <a:rPr lang="en-GB"/>
+              <a:t>Tâm Anh Oxford Partnership</a:t>
+            </a:r>
           </a:p>
         </p:txBody>
       </p:sp>
@@ -2791,8 +2691,8 @@
         </p:nvSpPr>
         <p:spPr>
           <a:xfrm>
-            <a:off x="6553200" y="4767263"/>
-            <a:ext cx="2133600" cy="273844"/>
+            <a:off x="8610600" y="6356350"/>
+            <a:ext cx="2743200" cy="365125"/>
           </a:xfrm>
           <a:prstGeom prst="rect">
             <a:avLst/>
@@ -2802,53 +2702,57 @@
           <a:bodyPr anchor="ctr" bIns="45720" lIns="91440" rIns="91440" rtlCol="0" tIns="45720" vert="horz"/>
           <a:lstStyle>
             <a:lvl1pPr algn="r">
-              <a:defRPr sz="900">
+              <a:defRPr sz="1200">
                 <a:solidFill>
                   <a:schemeClr val="tx1">
-                    <a:tint val="75000"/>
+                    <a:tint val="82000"/>
                   </a:schemeClr>
                 </a:solidFill>
               </a:defRPr>
             </a:lvl1pPr>
           </a:lstStyle>
           <a:p>
-            <a:fld id="{C5EF2332-01BF-834F-8236-50238282D533}" type="slidenum">
-              <a:rPr lang="en-US" smtClean="0"/>
+            <a:fld id="{330EA680-D336-4FF7-8B7A-9848BB0A1C32}" type="slidenum">
+              <a:rPr lang="en-GB" smtClean="0"/>
               <a:t>‹#›</a:t>
             </a:fld>
-            <a:endParaRPr lang="en-US"/>
+            <a:endParaRPr lang="en-GB"/>
           </a:p>
         </p:txBody>
       </p:sp>
     </p:spTree>
     <p:extLst>
       <p:ext uri="{BB962C8B-B14F-4D97-AF65-F5344CB8AC3E}">
-        <p14:creationId xmlns:p14="http://schemas.microsoft.com/office/powerpoint/2010/main" val="3676200875"/>
+        <p14:creationId xmlns:p14="http://schemas.microsoft.com/office/powerpoint/2010/main" val="2460954070"/>
       </p:ext>
     </p:extLst>
   </p:cSld>
   <p:clrMap accent1="accent1" accent2="accent2" accent3="accent3" accent4="accent4" accent5="accent5" accent6="accent6" bg1="lt1" bg2="lt2" folHlink="folHlink" hlink="hlink" tx1="dk1" tx2="dk2"/>
   <p:sldLayoutIdLst>
-    <p:sldLayoutId id="2147483649" r:id="rId1"/>
-    <p:sldLayoutId id="2147483650" r:id="rId2"/>
-    <p:sldLayoutId id="2147483651" r:id="rId3"/>
-    <p:sldLayoutId id="2147483652" r:id="rId4"/>
-    <p:sldLayoutId id="2147483653" r:id="rId5"/>
-    <p:sldLayoutId id="2147483654" r:id="rId6"/>
-    <p:sldLayoutId id="2147483655" r:id="rId7"/>
-    <p:sldLayoutId id="2147483656" r:id="rId8"/>
-    <p:sldLayoutId id="2147483657" r:id="rId9"/>
-    <p:sldLayoutId id="2147483658" r:id="rId10"/>
-    <p:sldLayoutId id="2147483659" r:id="rId11"/>
+    <p:sldLayoutId id="2147483661" r:id="rId1"/>
+    <p:sldLayoutId id="2147483662" r:id="rId2"/>
+    <p:sldLayoutId id="2147483663" r:id="rId3"/>
+    <p:sldLayoutId id="2147483664" r:id="rId4"/>
+    <p:sldLayoutId id="2147483665" r:id="rId5"/>
+    <p:sldLayoutId id="2147483666" r:id="rId6"/>
+    <p:sldLayoutId id="2147483667" r:id="rId7"/>
+    <p:sldLayoutId id="2147483668" r:id="rId8"/>
+    <p:sldLayoutId id="2147483669" r:id="rId9"/>
+    <p:sldLayoutId id="2147483670" r:id="rId10"/>
+    <p:sldLayoutId id="2147483671" r:id="rId11"/>
   </p:sldLayoutIdLst>
+  <p:hf dt="0" hdr="0"/>
   <p:txStyles>
     <p:titleStyle>
-      <a:lvl1pPr algn="ctr" defTabSz="342900" eaLnBrk="1" hangingPunct="1" latinLnBrk="0" rtl="0">
+      <a:lvl1pPr algn="l" defTabSz="914400" eaLnBrk="1" hangingPunct="1" latinLnBrk="0" rtl="0">
+        <a:lnSpc>
+          <a:spcPct val="90000"/>
+        </a:lnSpc>
         <a:spcBef>
           <a:spcPct val="0"/>
         </a:spcBef>
         <a:buNone/>
-        <a:defRPr kern="1200" sz="3300">
+        <a:defRPr kern="1200" sz="4400">
           <a:solidFill>
             <a:schemeClr val="tx1"/>
           </a:solidFill>
@@ -2859,11 +2763,32 @@
       </a:lvl1pPr>
     </p:titleStyle>
     <p:bodyStyle>
-      <a:lvl1pPr algn="l" defTabSz="342900" eaLnBrk="1" hangingPunct="1" indent="-342900" latinLnBrk="0" marL="342900" rtl="0">
+      <a:lvl1pPr algn="l" defTabSz="914400" eaLnBrk="1" hangingPunct="1" indent="-228600" latinLnBrk="0" marL="228600" rtl="0">
+        <a:lnSpc>
+          <a:spcPct val="90000"/>
+        </a:lnSpc>
         <a:spcBef>
-          <a:spcPct val="20000"/>
+          <a:spcPts val="1000"/>
         </a:spcBef>
-        <a:buFont typeface="Arial"/>
+        <a:buFont charset="0" panose="020B0604020202020204" pitchFamily="34" typeface="Arial"/>
+        <a:buChar char="•"/>
+        <a:defRPr kern="1200" sz="2800">
+          <a:solidFill>
+            <a:schemeClr val="tx1"/>
+          </a:solidFill>
+          <a:latin typeface="+mn-lt"/>
+          <a:ea typeface="+mn-ea"/>
+          <a:cs typeface="+mn-cs"/>
+        </a:defRPr>
+      </a:lvl1pPr>
+      <a:lvl2pPr algn="l" defTabSz="914400" eaLnBrk="1" hangingPunct="1" indent="-228600" latinLnBrk="0" marL="685800" rtl="0">
+        <a:lnSpc>
+          <a:spcPct val="90000"/>
+        </a:lnSpc>
+        <a:spcBef>
+          <a:spcPts val="500"/>
+        </a:spcBef>
+        <a:buFont charset="0" panose="020B0604020202020204" pitchFamily="34" typeface="Arial"/>
         <a:buChar char="•"/>
         <a:defRPr kern="1200" sz="2400">
           <a:solidFill>
@@ -2873,14 +2798,17 @@
           <a:ea typeface="+mn-ea"/>
           <a:cs typeface="+mn-cs"/>
         </a:defRPr>
-      </a:lvl1pPr>
-      <a:lvl2pPr algn="l" defTabSz="342900" eaLnBrk="1" hangingPunct="1" indent="-342900" latinLnBrk="0" marL="685800" rtl="0">
+      </a:lvl2pPr>
+      <a:lvl3pPr algn="l" defTabSz="914400" eaLnBrk="1" hangingPunct="1" indent="-228600" latinLnBrk="0" marL="1143000" rtl="0">
+        <a:lnSpc>
+          <a:spcPct val="90000"/>
+        </a:lnSpc>
         <a:spcBef>
-          <a:spcPct val="20000"/>
+          <a:spcPts val="500"/>
         </a:spcBef>
-        <a:buFont typeface="Arial"/>
-        <a:buChar char="–"/>
-        <a:defRPr kern="1200" sz="2100">
+        <a:buFont charset="0" panose="020B0604020202020204" pitchFamily="34" typeface="Arial"/>
+        <a:buChar char="•"/>
+        <a:defRPr kern="1200" sz="2000">
           <a:solidFill>
             <a:schemeClr val="tx1"/>
           </a:solidFill>
@@ -2888,12 +2816,15 @@
           <a:ea typeface="+mn-ea"/>
           <a:cs typeface="+mn-cs"/>
         </a:defRPr>
-      </a:lvl2pPr>
-      <a:lvl3pPr algn="l" defTabSz="342900" eaLnBrk="1" hangingPunct="1" indent="-342900" latinLnBrk="0" marL="1028700" rtl="0">
+      </a:lvl3pPr>
+      <a:lvl4pPr algn="l" defTabSz="914400" eaLnBrk="1" hangingPunct="1" indent="-228600" latinLnBrk="0" marL="1600200" rtl="0">
+        <a:lnSpc>
+          <a:spcPct val="90000"/>
+        </a:lnSpc>
         <a:spcBef>
-          <a:spcPct val="20000"/>
+          <a:spcPts val="500"/>
         </a:spcBef>
-        <a:buFont typeface="Arial"/>
+        <a:buFont charset="0" panose="020B0604020202020204" pitchFamily="34" typeface="Arial"/>
         <a:buChar char="•"/>
         <a:defRPr kern="1200" sz="1800">
           <a:solidFill>
@@ -2903,29 +2834,17 @@
           <a:ea typeface="+mn-ea"/>
           <a:cs typeface="+mn-cs"/>
         </a:defRPr>
-      </a:lvl3pPr>
-      <a:lvl4pPr algn="l" defTabSz="342900" eaLnBrk="1" hangingPunct="1" indent="-342900" latinLnBrk="0" marL="1371600" rtl="0">
+      </a:lvl4pPr>
+      <a:lvl5pPr algn="l" defTabSz="914400" eaLnBrk="1" hangingPunct="1" indent="-228600" latinLnBrk="0" marL="2057400" rtl="0">
+        <a:lnSpc>
+          <a:spcPct val="90000"/>
+        </a:lnSpc>
         <a:spcBef>
-          <a:spcPct val="20000"/>
+          <a:spcPts val="500"/>
         </a:spcBef>
-        <a:buFont typeface="Arial"/>
-        <a:buChar char="–"/>
-        <a:defRPr kern="1200" sz="1500">
-          <a:solidFill>
-            <a:schemeClr val="tx1"/>
-          </a:solidFill>
-          <a:latin typeface="+mn-lt"/>
-          <a:ea typeface="+mn-ea"/>
-          <a:cs typeface="+mn-cs"/>
-        </a:defRPr>
-      </a:lvl4pPr>
-      <a:lvl5pPr algn="l" defTabSz="342900" eaLnBrk="1" hangingPunct="1" indent="-342900" latinLnBrk="0" marL="1714500" rtl="0">
-        <a:spcBef>
-          <a:spcPct val="20000"/>
-        </a:spcBef>
-        <a:buFont typeface="Arial"/>
-        <a:buChar char="»"/>
-        <a:defRPr kern="1200" sz="1500">
+        <a:buFont charset="0" panose="020B0604020202020204" pitchFamily="34" typeface="Arial"/>
+        <a:buChar char="•"/>
+        <a:defRPr kern="1200" sz="1800">
           <a:solidFill>
             <a:schemeClr val="tx1"/>
           </a:solidFill>
@@ -2934,13 +2853,16 @@
           <a:cs typeface="+mn-cs"/>
         </a:defRPr>
       </a:lvl5pPr>
-      <a:lvl6pPr algn="l" defTabSz="342900" eaLnBrk="1" hangingPunct="1" indent="-342900" latinLnBrk="0" marL="2057400" rtl="0">
+      <a:lvl6pPr algn="l" defTabSz="914400" eaLnBrk="1" hangingPunct="1" indent="-228600" latinLnBrk="0" marL="2514600" rtl="0">
+        <a:lnSpc>
+          <a:spcPct val="90000"/>
+        </a:lnSpc>
         <a:spcBef>
-          <a:spcPct val="20000"/>
+          <a:spcPts val="500"/>
         </a:spcBef>
-        <a:buFont typeface="Arial"/>
+        <a:buFont charset="0" panose="020B0604020202020204" pitchFamily="34" typeface="Arial"/>
         <a:buChar char="•"/>
-        <a:defRPr kern="1200" sz="1500">
+        <a:defRPr kern="1200" sz="1800">
           <a:solidFill>
             <a:schemeClr val="tx1"/>
           </a:solidFill>
@@ -2949,13 +2871,16 @@
           <a:cs typeface="+mn-cs"/>
         </a:defRPr>
       </a:lvl6pPr>
-      <a:lvl7pPr algn="l" defTabSz="342900" eaLnBrk="1" hangingPunct="1" indent="-342900" latinLnBrk="0" marL="2400300" rtl="0">
+      <a:lvl7pPr algn="l" defTabSz="914400" eaLnBrk="1" hangingPunct="1" indent="-228600" latinLnBrk="0" marL="2971800" rtl="0">
+        <a:lnSpc>
+          <a:spcPct val="90000"/>
+        </a:lnSpc>
         <a:spcBef>
-          <a:spcPct val="20000"/>
+          <a:spcPts val="500"/>
         </a:spcBef>
-        <a:buFont typeface="Arial"/>
+        <a:buFont charset="0" panose="020B0604020202020204" pitchFamily="34" typeface="Arial"/>
         <a:buChar char="•"/>
-        <a:defRPr kern="1200" sz="1500">
+        <a:defRPr kern="1200" sz="1800">
           <a:solidFill>
             <a:schemeClr val="tx1"/>
           </a:solidFill>
@@ -2964,13 +2889,16 @@
           <a:cs typeface="+mn-cs"/>
         </a:defRPr>
       </a:lvl7pPr>
-      <a:lvl8pPr algn="l" defTabSz="342900" eaLnBrk="1" hangingPunct="1" indent="-342900" latinLnBrk="0" marL="2743200" rtl="0">
+      <a:lvl8pPr algn="l" defTabSz="914400" eaLnBrk="1" hangingPunct="1" indent="-228600" latinLnBrk="0" marL="3429000" rtl="0">
+        <a:lnSpc>
+          <a:spcPct val="90000"/>
+        </a:lnSpc>
         <a:spcBef>
-          <a:spcPct val="20000"/>
+          <a:spcPts val="500"/>
         </a:spcBef>
-        <a:buFont typeface="Arial"/>
+        <a:buFont charset="0" panose="020B0604020202020204" pitchFamily="34" typeface="Arial"/>
         <a:buChar char="•"/>
-        <a:defRPr kern="1200" sz="1500">
+        <a:defRPr kern="1200" sz="1800">
           <a:solidFill>
             <a:schemeClr val="tx1"/>
           </a:solidFill>
@@ -2979,13 +2907,16 @@
           <a:cs typeface="+mn-cs"/>
         </a:defRPr>
       </a:lvl8pPr>
-      <a:lvl9pPr algn="l" defTabSz="342900" eaLnBrk="1" hangingPunct="1" indent="-342900" latinLnBrk="0" marL="3086100" rtl="0">
+      <a:lvl9pPr algn="l" defTabSz="914400" eaLnBrk="1" hangingPunct="1" indent="-228600" latinLnBrk="0" marL="3886200" rtl="0">
+        <a:lnSpc>
+          <a:spcPct val="90000"/>
+        </a:lnSpc>
         <a:spcBef>
-          <a:spcPct val="20000"/>
+          <a:spcPts val="500"/>
         </a:spcBef>
-        <a:buFont typeface="Arial"/>
+        <a:buFont charset="0" panose="020B0604020202020204" pitchFamily="34" typeface="Arial"/>
         <a:buChar char="•"/>
-        <a:defRPr kern="1200" sz="1500">
+        <a:defRPr kern="1200" sz="1800">
           <a:solidFill>
             <a:schemeClr val="tx1"/>
           </a:solidFill>
@@ -2997,10 +2928,10 @@
     </p:bodyStyle>
     <p:otherStyle>
       <a:defPPr>
-        <a:defRPr lang="en-US"/>
+        <a:defRPr lang="en-GB"/>
       </a:defPPr>
-      <a:lvl1pPr algn="l" defTabSz="342900" eaLnBrk="1" hangingPunct="1" latinLnBrk="0" marL="0" rtl="0">
-        <a:defRPr kern="1200" sz="1350">
+      <a:lvl1pPr algn="l" defTabSz="914400" eaLnBrk="1" hangingPunct="1" latinLnBrk="0" marL="0" rtl="0">
+        <a:defRPr kern="1200" sz="1800">
           <a:solidFill>
             <a:schemeClr val="tx1"/>
           </a:solidFill>
@@ -3009,8 +2940,8 @@
           <a:cs typeface="+mn-cs"/>
         </a:defRPr>
       </a:lvl1pPr>
-      <a:lvl2pPr algn="l" defTabSz="342900" eaLnBrk="1" hangingPunct="1" latinLnBrk="0" marL="342900" rtl="0">
-        <a:defRPr kern="1200" sz="1350">
+      <a:lvl2pPr algn="l" defTabSz="914400" eaLnBrk="1" hangingPunct="1" latinLnBrk="0" marL="457200" rtl="0">
+        <a:defRPr kern="1200" sz="1800">
           <a:solidFill>
             <a:schemeClr val="tx1"/>
           </a:solidFill>
@@ -3019,8 +2950,8 @@
           <a:cs typeface="+mn-cs"/>
         </a:defRPr>
       </a:lvl2pPr>
-      <a:lvl3pPr algn="l" defTabSz="342900" eaLnBrk="1" hangingPunct="1" latinLnBrk="0" marL="685800" rtl="0">
-        <a:defRPr kern="1200" sz="1350">
+      <a:lvl3pPr algn="l" defTabSz="914400" eaLnBrk="1" hangingPunct="1" latinLnBrk="0" marL="914400" rtl="0">
+        <a:defRPr kern="1200" sz="1800">
           <a:solidFill>
             <a:schemeClr val="tx1"/>
           </a:solidFill>
@@ -3029,8 +2960,8 @@
           <a:cs typeface="+mn-cs"/>
         </a:defRPr>
       </a:lvl3pPr>
-      <a:lvl4pPr algn="l" defTabSz="342900" eaLnBrk="1" hangingPunct="1" latinLnBrk="0" marL="1028700" rtl="0">
-        <a:defRPr kern="1200" sz="1350">
+      <a:lvl4pPr algn="l" defTabSz="914400" eaLnBrk="1" hangingPunct="1" latinLnBrk="0" marL="1371600" rtl="0">
+        <a:defRPr kern="1200" sz="1800">
           <a:solidFill>
             <a:schemeClr val="tx1"/>
           </a:solidFill>
@@ -3039,8 +2970,8 @@
           <a:cs typeface="+mn-cs"/>
         </a:defRPr>
       </a:lvl4pPr>
-      <a:lvl5pPr algn="l" defTabSz="342900" eaLnBrk="1" hangingPunct="1" latinLnBrk="0" marL="1371600" rtl="0">
-        <a:defRPr kern="1200" sz="1350">
+      <a:lvl5pPr algn="l" defTabSz="914400" eaLnBrk="1" hangingPunct="1" latinLnBrk="0" marL="1828800" rtl="0">
+        <a:defRPr kern="1200" sz="1800">
           <a:solidFill>
             <a:schemeClr val="tx1"/>
           </a:solidFill>
@@ -3049,8 +2980,8 @@
           <a:cs typeface="+mn-cs"/>
         </a:defRPr>
       </a:lvl5pPr>
-      <a:lvl6pPr algn="l" defTabSz="342900" eaLnBrk="1" hangingPunct="1" latinLnBrk="0" marL="1714500" rtl="0">
-        <a:defRPr kern="1200" sz="1350">
+      <a:lvl6pPr algn="l" defTabSz="914400" eaLnBrk="1" hangingPunct="1" latinLnBrk="0" marL="2286000" rtl="0">
+        <a:defRPr kern="1200" sz="1800">
           <a:solidFill>
             <a:schemeClr val="tx1"/>
           </a:solidFill>
@@ -3059,8 +2990,8 @@
           <a:cs typeface="+mn-cs"/>
         </a:defRPr>
       </a:lvl6pPr>
-      <a:lvl7pPr algn="l" defTabSz="342900" eaLnBrk="1" hangingPunct="1" latinLnBrk="0" marL="2057400" rtl="0">
-        <a:defRPr kern="1200" sz="1350">
+      <a:lvl7pPr algn="l" defTabSz="914400" eaLnBrk="1" hangingPunct="1" latinLnBrk="0" marL="2743200" rtl="0">
+        <a:defRPr kern="1200" sz="1800">
           <a:solidFill>
             <a:schemeClr val="tx1"/>
           </a:solidFill>
@@ -3069,8 +3000,8 @@
           <a:cs typeface="+mn-cs"/>
         </a:defRPr>
       </a:lvl7pPr>
-      <a:lvl8pPr algn="l" defTabSz="342900" eaLnBrk="1" hangingPunct="1" latinLnBrk="0" marL="2400300" rtl="0">
-        <a:defRPr kern="1200" sz="1350">
+      <a:lvl8pPr algn="l" defTabSz="914400" eaLnBrk="1" hangingPunct="1" latinLnBrk="0" marL="3200400" rtl="0">
+        <a:defRPr kern="1200" sz="1800">
           <a:solidFill>
             <a:schemeClr val="tx1"/>
           </a:solidFill>
@@ -3079,8 +3010,8 @@
           <a:cs typeface="+mn-cs"/>
         </a:defRPr>
       </a:lvl8pPr>
-      <a:lvl9pPr algn="l" defTabSz="342900" eaLnBrk="1" hangingPunct="1" latinLnBrk="0" marL="2743200" rtl="0">
-        <a:defRPr kern="1200" sz="1350">
+      <a:lvl9pPr algn="l" defTabSz="914400" eaLnBrk="1" hangingPunct="1" latinLnBrk="0" marL="3657600" rtl="0">
+        <a:defRPr kern="1200" sz="1800">
           <a:solidFill>
             <a:schemeClr val="tx1"/>
           </a:solidFill>
@@ -3123,8 +3054,8 @@
         </p:nvSpPr>
         <p:spPr>
           <a:xfrm>
-            <a:off x="685800" y="1597819"/>
-            <a:ext cx="7772400" cy="1102519"/>
+            <a:off x="1524000" y="1122363"/>
+            <a:ext cx="9144000" cy="2387600"/>
           </a:xfrm>
         </p:spPr>
         <p:txBody>
@@ -3153,8 +3084,8 @@
         </p:nvSpPr>
         <p:spPr>
           <a:xfrm>
-            <a:off x="1371600" y="2914650"/>
-            <a:ext cx="6400800" cy="1314450"/>
+            <a:off x="1524000" y="3602038"/>
+            <a:ext cx="9144000" cy="1655762"/>
           </a:xfrm>
         </p:spPr>
         <p:txBody>
@@ -3268,6 +3199,51 @@
           </a:p>
         </p:txBody>
       </p:sp>
+      <p:sp>
+        <p:nvSpPr>
+          <p:cNvPr id="5" name="Footer Placeholder 4"/>
+          <p:cNvSpPr>
+            <a:spLocks noGrp="1"/>
+          </p:cNvSpPr>
+          <p:nvPr>
+            <p:ph idx="11" sz="quarter" type="ftr"/>
+          </p:nvPr>
+        </p:nvSpPr>
+        <p:spPr/>
+        <p:txBody>
+          <a:bodyPr/>
+          <a:lstStyle/>
+          <a:p>
+            <a:r>
+              <a:rPr lang="en-GB"/>
+              <a:t>Tâm Anh Oxford Partnership</a:t>
+            </a:r>
+          </a:p>
+        </p:txBody>
+      </p:sp>
+      <p:sp>
+        <p:nvSpPr>
+          <p:cNvPr id="6" name="Slide Number Placeholder 5"/>
+          <p:cNvSpPr>
+            <a:spLocks noGrp="1"/>
+          </p:cNvSpPr>
+          <p:nvPr>
+            <p:ph idx="12" sz="quarter" type="sldNum"/>
+          </p:nvPr>
+        </p:nvSpPr>
+        <p:spPr/>
+        <p:txBody>
+          <a:bodyPr/>
+          <a:lstStyle/>
+          <a:p>
+            <a:fld id="{330EA680-D336-4FF7-8B7A-9848BB0A1C32}" type="slidenum">
+              <a:rPr lang="en-GB" smtClean="0"/>
+              <a:t>‹#›</a:t>
+            </a:fld>
+            <a:endParaRPr lang="en-GB"/>
+          </a:p>
+        </p:txBody>
+      </p:sp>
     </p:spTree>
   </p:cSld>
 </p:sld>
@@ -3373,6 +3349,51 @@
           </a:p>
         </p:txBody>
       </p:sp>
+      <p:sp>
+        <p:nvSpPr>
+          <p:cNvPr id="5" name="Footer Placeholder 4"/>
+          <p:cNvSpPr>
+            <a:spLocks noGrp="1"/>
+          </p:cNvSpPr>
+          <p:nvPr>
+            <p:ph idx="11" sz="quarter" type="ftr"/>
+          </p:nvPr>
+        </p:nvSpPr>
+        <p:spPr/>
+        <p:txBody>
+          <a:bodyPr/>
+          <a:lstStyle/>
+          <a:p>
+            <a:r>
+              <a:rPr lang="en-GB"/>
+              <a:t>Tâm Anh Oxford Partnership</a:t>
+            </a:r>
+          </a:p>
+        </p:txBody>
+      </p:sp>
+      <p:sp>
+        <p:nvSpPr>
+          <p:cNvPr id="6" name="Slide Number Placeholder 5"/>
+          <p:cNvSpPr>
+            <a:spLocks noGrp="1"/>
+          </p:cNvSpPr>
+          <p:nvPr>
+            <p:ph idx="12" sz="quarter" type="sldNum"/>
+          </p:nvPr>
+        </p:nvSpPr>
+        <p:spPr/>
+        <p:txBody>
+          <a:bodyPr/>
+          <a:lstStyle/>
+          <a:p>
+            <a:fld id="{330EA680-D336-4FF7-8B7A-9848BB0A1C32}" type="slidenum">
+              <a:rPr lang="en-GB" smtClean="0"/>
+              <a:t>‹#›</a:t>
+            </a:fld>
+            <a:endParaRPr lang="en-GB"/>
+          </a:p>
+        </p:txBody>
+      </p:sp>
     </p:spTree>
   </p:cSld>
 </p:sld>
@@ -3471,6 +3492,51 @@
           </a:p>
         </p:txBody>
       </p:sp>
+      <p:sp>
+        <p:nvSpPr>
+          <p:cNvPr id="5" name="Footer Placeholder 4"/>
+          <p:cNvSpPr>
+            <a:spLocks noGrp="1"/>
+          </p:cNvSpPr>
+          <p:nvPr>
+            <p:ph idx="11" sz="quarter" type="ftr"/>
+          </p:nvPr>
+        </p:nvSpPr>
+        <p:spPr/>
+        <p:txBody>
+          <a:bodyPr/>
+          <a:lstStyle/>
+          <a:p>
+            <a:r>
+              <a:rPr lang="en-GB"/>
+              <a:t>Tâm Anh Oxford Partnership</a:t>
+            </a:r>
+          </a:p>
+        </p:txBody>
+      </p:sp>
+      <p:sp>
+        <p:nvSpPr>
+          <p:cNvPr id="6" name="Slide Number Placeholder 5"/>
+          <p:cNvSpPr>
+            <a:spLocks noGrp="1"/>
+          </p:cNvSpPr>
+          <p:nvPr>
+            <p:ph idx="12" sz="quarter" type="sldNum"/>
+          </p:nvPr>
+        </p:nvSpPr>
+        <p:spPr/>
+        <p:txBody>
+          <a:bodyPr/>
+          <a:lstStyle/>
+          <a:p>
+            <a:fld id="{330EA680-D336-4FF7-8B7A-9848BB0A1C32}" type="slidenum">
+              <a:rPr lang="en-GB" smtClean="0"/>
+              <a:t>‹#›</a:t>
+            </a:fld>
+            <a:endParaRPr lang="en-GB"/>
+          </a:p>
+        </p:txBody>
+      </p:sp>
     </p:spTree>
   </p:cSld>
 </p:sld>
@@ -3562,6 +3628,51 @@
           </a:p>
         </p:txBody>
       </p:sp>
+      <p:sp>
+        <p:nvSpPr>
+          <p:cNvPr id="5" name="Footer Placeholder 4"/>
+          <p:cNvSpPr>
+            <a:spLocks noGrp="1"/>
+          </p:cNvSpPr>
+          <p:nvPr>
+            <p:ph idx="11" sz="quarter" type="ftr"/>
+          </p:nvPr>
+        </p:nvSpPr>
+        <p:spPr/>
+        <p:txBody>
+          <a:bodyPr/>
+          <a:lstStyle/>
+          <a:p>
+            <a:r>
+              <a:rPr lang="en-GB"/>
+              <a:t>Tâm Anh Oxford Partnership</a:t>
+            </a:r>
+          </a:p>
+        </p:txBody>
+      </p:sp>
+      <p:sp>
+        <p:nvSpPr>
+          <p:cNvPr id="6" name="Slide Number Placeholder 5"/>
+          <p:cNvSpPr>
+            <a:spLocks noGrp="1"/>
+          </p:cNvSpPr>
+          <p:nvPr>
+            <p:ph idx="12" sz="quarter" type="sldNum"/>
+          </p:nvPr>
+        </p:nvSpPr>
+        <p:spPr/>
+        <p:txBody>
+          <a:bodyPr/>
+          <a:lstStyle/>
+          <a:p>
+            <a:fld id="{330EA680-D336-4FF7-8B7A-9848BB0A1C32}" type="slidenum">
+              <a:rPr lang="en-GB" smtClean="0"/>
+              <a:t>‹#›</a:t>
+            </a:fld>
+            <a:endParaRPr lang="en-GB"/>
+          </a:p>
+        </p:txBody>
+      </p:sp>
     </p:spTree>
   </p:cSld>
 </p:sld>
@@ -3653,6 +3764,51 @@
           </a:p>
         </p:txBody>
       </p:sp>
+      <p:sp>
+        <p:nvSpPr>
+          <p:cNvPr id="5" name="Footer Placeholder 4"/>
+          <p:cNvSpPr>
+            <a:spLocks noGrp="1"/>
+          </p:cNvSpPr>
+          <p:nvPr>
+            <p:ph idx="11" sz="quarter" type="ftr"/>
+          </p:nvPr>
+        </p:nvSpPr>
+        <p:spPr/>
+        <p:txBody>
+          <a:bodyPr/>
+          <a:lstStyle/>
+          <a:p>
+            <a:r>
+              <a:rPr lang="en-GB"/>
+              <a:t>Tâm Anh Oxford Partnership</a:t>
+            </a:r>
+          </a:p>
+        </p:txBody>
+      </p:sp>
+      <p:sp>
+        <p:nvSpPr>
+          <p:cNvPr id="6" name="Slide Number Placeholder 5"/>
+          <p:cNvSpPr>
+            <a:spLocks noGrp="1"/>
+          </p:cNvSpPr>
+          <p:nvPr>
+            <p:ph idx="12" sz="quarter" type="sldNum"/>
+          </p:nvPr>
+        </p:nvSpPr>
+        <p:spPr/>
+        <p:txBody>
+          <a:bodyPr/>
+          <a:lstStyle/>
+          <a:p>
+            <a:fld id="{330EA680-D336-4FF7-8B7A-9848BB0A1C32}" type="slidenum">
+              <a:rPr lang="en-GB" smtClean="0"/>
+              <a:t>‹#›</a:t>
+            </a:fld>
+            <a:endParaRPr lang="en-GB"/>
+          </a:p>
+        </p:txBody>
+      </p:sp>
     </p:spTree>
   </p:cSld>
 </p:sld>
@@ -3700,6 +3856,51 @@
           </a:p>
         </p:txBody>
       </p:sp>
+      <p:sp>
+        <p:nvSpPr>
+          <p:cNvPr id="5" name="Footer Placeholder 4"/>
+          <p:cNvSpPr>
+            <a:spLocks noGrp="1"/>
+          </p:cNvSpPr>
+          <p:nvPr>
+            <p:ph idx="11" sz="quarter" type="ftr"/>
+          </p:nvPr>
+        </p:nvSpPr>
+        <p:spPr/>
+        <p:txBody>
+          <a:bodyPr/>
+          <a:lstStyle/>
+          <a:p>
+            <a:r>
+              <a:rPr lang="en-GB"/>
+              <a:t>Tâm Anh Oxford Partnership</a:t>
+            </a:r>
+          </a:p>
+        </p:txBody>
+      </p:sp>
+      <p:sp>
+        <p:nvSpPr>
+          <p:cNvPr id="6" name="Slide Number Placeholder 5"/>
+          <p:cNvSpPr>
+            <a:spLocks noGrp="1"/>
+          </p:cNvSpPr>
+          <p:nvPr>
+            <p:ph idx="12" sz="quarter" type="sldNum"/>
+          </p:nvPr>
+        </p:nvSpPr>
+        <p:spPr/>
+        <p:txBody>
+          <a:bodyPr/>
+          <a:lstStyle/>
+          <a:p>
+            <a:fld id="{330EA680-D336-4FF7-8B7A-9848BB0A1C32}" type="slidenum">
+              <a:rPr lang="en-GB" smtClean="0"/>
+              <a:t>‹#›</a:t>
+            </a:fld>
+            <a:endParaRPr lang="en-GB"/>
+          </a:p>
+        </p:txBody>
+      </p:sp>
     </p:spTree>
   </p:cSld>
 </p:sld>
@@ -3732,7 +3933,12 @@
             <p:ph type="title"/>
           </p:nvPr>
         </p:nvSpPr>
-        <p:spPr/>
+        <p:spPr>
+          <a:xfrm>
+            <a:off x="839788" y="365125"/>
+            <a:ext cx="10515600" cy="1325563"/>
+          </a:xfrm>
+        </p:spPr>
         <p:txBody>
           <a:bodyPr/>
           <a:lstStyle/>
@@ -3788,8 +3994,8 @@
         </p:blipFill>
         <p:spPr bwMode="auto">
           <a:xfrm>
-            <a:off x="584200" y="1625600"/>
-            <a:ext cx="3771900" cy="2959100"/>
+            <a:off x="1066800" y="2501900"/>
+            <a:ext cx="4699000" cy="3683000"/>
           </a:xfrm>
           <a:prstGeom prst="rect">
             <a:avLst/>
@@ -3843,8 +4049,8 @@
         </p:blipFill>
         <p:spPr bwMode="auto">
           <a:xfrm>
-            <a:off x="4762500" y="1625600"/>
-            <a:ext cx="3771900" cy="2959100"/>
+            <a:off x="6413500" y="2501900"/>
+            <a:ext cx="4699000" cy="3683000"/>
           </a:xfrm>
           <a:prstGeom prst="rect">
             <a:avLst/>
@@ -3857,6 +4063,51 @@
           </a:ln>
         </p:spPr>
       </p:pic>
+      <p:sp>
+        <p:nvSpPr>
+          <p:cNvPr id="8" name="Footer Placeholder 7"/>
+          <p:cNvSpPr>
+            <a:spLocks noGrp="1"/>
+          </p:cNvSpPr>
+          <p:nvPr>
+            <p:ph idx="11" sz="quarter" type="ftr"/>
+          </p:nvPr>
+        </p:nvSpPr>
+        <p:spPr/>
+        <p:txBody>
+          <a:bodyPr/>
+          <a:lstStyle/>
+          <a:p>
+            <a:r>
+              <a:rPr lang="en-GB"/>
+              <a:t>Tâm Anh Oxford Partnership</a:t>
+            </a:r>
+          </a:p>
+        </p:txBody>
+      </p:sp>
+      <p:sp>
+        <p:nvSpPr>
+          <p:cNvPr id="9" name="Slide Number Placeholder 8"/>
+          <p:cNvSpPr>
+            <a:spLocks noGrp="1"/>
+          </p:cNvSpPr>
+          <p:nvPr>
+            <p:ph idx="12" sz="quarter" type="sldNum"/>
+          </p:nvPr>
+        </p:nvSpPr>
+        <p:spPr/>
+        <p:txBody>
+          <a:bodyPr/>
+          <a:lstStyle/>
+          <a:p>
+            <a:fld id="{330EA680-D336-4FF7-8B7A-9848BB0A1C32}" type="slidenum">
+              <a:rPr lang="en-GB" smtClean="0"/>
+              <a:t>‹#›</a:t>
+            </a:fld>
+            <a:endParaRPr lang="en-GB"/>
+          </a:p>
+        </p:txBody>
+      </p:sp>
     </p:spTree>
   </p:cSld>
 </p:sld>
@@ -3920,8 +4171,8 @@
         </p:blipFill>
         <p:spPr bwMode="auto">
           <a:xfrm>
-            <a:off x="1524000" y="1193800"/>
-            <a:ext cx="6096000" cy="3390900"/>
+            <a:off x="2184400" y="1816100"/>
+            <a:ext cx="7810500" cy="4343400"/>
           </a:xfrm>
           <a:prstGeom prst="rect">
             <a:avLst/>
@@ -3934,6 +4185,51 @@
           </a:ln>
         </p:spPr>
       </p:pic>
+      <p:sp>
+        <p:nvSpPr>
+          <p:cNvPr id="5" name="Footer Placeholder 4"/>
+          <p:cNvSpPr>
+            <a:spLocks noGrp="1"/>
+          </p:cNvSpPr>
+          <p:nvPr>
+            <p:ph idx="11" sz="quarter" type="ftr"/>
+          </p:nvPr>
+        </p:nvSpPr>
+        <p:spPr/>
+        <p:txBody>
+          <a:bodyPr/>
+          <a:lstStyle/>
+          <a:p>
+            <a:r>
+              <a:rPr lang="en-GB"/>
+              <a:t>Tâm Anh Oxford Partnership</a:t>
+            </a:r>
+          </a:p>
+        </p:txBody>
+      </p:sp>
+      <p:sp>
+        <p:nvSpPr>
+          <p:cNvPr id="6" name="Slide Number Placeholder 5"/>
+          <p:cNvSpPr>
+            <a:spLocks noGrp="1"/>
+          </p:cNvSpPr>
+          <p:nvPr>
+            <p:ph idx="12" sz="quarter" type="sldNum"/>
+          </p:nvPr>
+        </p:nvSpPr>
+        <p:spPr/>
+        <p:txBody>
+          <a:bodyPr/>
+          <a:lstStyle/>
+          <a:p>
+            <a:fld id="{330EA680-D336-4FF7-8B7A-9848BB0A1C32}" type="slidenum">
+              <a:rPr lang="en-GB" smtClean="0"/>
+              <a:t>‹#›</a:t>
+            </a:fld>
+            <a:endParaRPr lang="en-GB"/>
+          </a:p>
+        </p:txBody>
+      </p:sp>
     </p:spTree>
   </p:cSld>
 </p:sld>
@@ -4053,6 +4349,51 @@
           </a:p>
         </p:txBody>
       </p:sp>
+      <p:sp>
+        <p:nvSpPr>
+          <p:cNvPr id="5" name="Footer Placeholder 4"/>
+          <p:cNvSpPr>
+            <a:spLocks noGrp="1"/>
+          </p:cNvSpPr>
+          <p:nvPr>
+            <p:ph idx="11" sz="quarter" type="ftr"/>
+          </p:nvPr>
+        </p:nvSpPr>
+        <p:spPr/>
+        <p:txBody>
+          <a:bodyPr/>
+          <a:lstStyle/>
+          <a:p>
+            <a:r>
+              <a:rPr lang="en-GB"/>
+              <a:t>Tâm Anh Oxford Partnership</a:t>
+            </a:r>
+          </a:p>
+        </p:txBody>
+      </p:sp>
+      <p:sp>
+        <p:nvSpPr>
+          <p:cNvPr id="6" name="Slide Number Placeholder 5"/>
+          <p:cNvSpPr>
+            <a:spLocks noGrp="1"/>
+          </p:cNvSpPr>
+          <p:nvPr>
+            <p:ph idx="12" sz="quarter" type="sldNum"/>
+          </p:nvPr>
+        </p:nvSpPr>
+        <p:spPr/>
+        <p:txBody>
+          <a:bodyPr/>
+          <a:lstStyle/>
+          <a:p>
+            <a:fld id="{330EA680-D336-4FF7-8B7A-9848BB0A1C32}" type="slidenum">
+              <a:rPr lang="en-GB" smtClean="0"/>
+              <a:t>‹#›</a:t>
+            </a:fld>
+            <a:endParaRPr lang="en-GB"/>
+          </a:p>
+        </p:txBody>
+      </p:sp>
     </p:spTree>
   </p:cSld>
 </p:sld>
@@ -4085,7 +4426,12 @@
             <p:ph type="title"/>
           </p:nvPr>
         </p:nvSpPr>
-        <p:spPr/>
+        <p:spPr>
+          <a:xfrm>
+            <a:off x="839788" y="365125"/>
+            <a:ext cx="10515600" cy="1325563"/>
+          </a:xfrm>
+        </p:spPr>
         <p:txBody>
           <a:bodyPr/>
           <a:lstStyle/>
@@ -4141,8 +4487,8 @@
         </p:blipFill>
         <p:spPr bwMode="auto">
           <a:xfrm>
-            <a:off x="457200" y="2247900"/>
-            <a:ext cx="4038600" cy="1714500"/>
+            <a:off x="838200" y="3251200"/>
+            <a:ext cx="5156200" cy="2184400"/>
           </a:xfrm>
           <a:prstGeom prst="rect">
             <a:avLst/>
@@ -4196,8 +4542,8 @@
         </p:blipFill>
         <p:spPr bwMode="auto">
           <a:xfrm>
-            <a:off x="4635500" y="2070100"/>
-            <a:ext cx="4038600" cy="2082800"/>
+            <a:off x="6172200" y="3009900"/>
+            <a:ext cx="5181600" cy="2667000"/>
           </a:xfrm>
           <a:prstGeom prst="rect">
             <a:avLst/>
@@ -4210,6 +4556,51 @@
           </a:ln>
         </p:spPr>
       </p:pic>
+      <p:sp>
+        <p:nvSpPr>
+          <p:cNvPr id="8" name="Footer Placeholder 7"/>
+          <p:cNvSpPr>
+            <a:spLocks noGrp="1"/>
+          </p:cNvSpPr>
+          <p:nvPr>
+            <p:ph idx="11" sz="quarter" type="ftr"/>
+          </p:nvPr>
+        </p:nvSpPr>
+        <p:spPr/>
+        <p:txBody>
+          <a:bodyPr/>
+          <a:lstStyle/>
+          <a:p>
+            <a:r>
+              <a:rPr lang="en-GB"/>
+              <a:t>Tâm Anh Oxford Partnership</a:t>
+            </a:r>
+          </a:p>
+        </p:txBody>
+      </p:sp>
+      <p:sp>
+        <p:nvSpPr>
+          <p:cNvPr id="9" name="Slide Number Placeholder 8"/>
+          <p:cNvSpPr>
+            <a:spLocks noGrp="1"/>
+          </p:cNvSpPr>
+          <p:nvPr>
+            <p:ph idx="12" sz="quarter" type="sldNum"/>
+          </p:nvPr>
+        </p:nvSpPr>
+        <p:spPr/>
+        <p:txBody>
+          <a:bodyPr/>
+          <a:lstStyle/>
+          <a:p>
+            <a:fld id="{330EA680-D336-4FF7-8B7A-9848BB0A1C32}" type="slidenum">
+              <a:rPr lang="en-GB" smtClean="0"/>
+              <a:t>‹#›</a:t>
+            </a:fld>
+            <a:endParaRPr lang="en-GB"/>
+          </a:p>
+        </p:txBody>
+      </p:sp>
     </p:spTree>
   </p:cSld>
 </p:sld>
@@ -4248,8 +4639,8 @@
         </p:blipFill>
         <p:spPr bwMode="auto">
           <a:xfrm>
-            <a:off x="2032000" y="1193800"/>
-            <a:ext cx="5080000" cy="3390900"/>
+            <a:off x="2844800" y="1816100"/>
+            <a:ext cx="6515100" cy="4343400"/>
           </a:xfrm>
           <a:prstGeom prst="rect">
             <a:avLst/>
@@ -4262,6 +4653,51 @@
           </a:ln>
         </p:spPr>
       </p:pic>
+      <p:sp>
+        <p:nvSpPr>
+          <p:cNvPr id="5" name="Footer Placeholder 4"/>
+          <p:cNvSpPr>
+            <a:spLocks noGrp="1"/>
+          </p:cNvSpPr>
+          <p:nvPr>
+            <p:ph idx="11" sz="quarter" type="ftr"/>
+          </p:nvPr>
+        </p:nvSpPr>
+        <p:spPr/>
+        <p:txBody>
+          <a:bodyPr/>
+          <a:lstStyle/>
+          <a:p>
+            <a:r>
+              <a:rPr lang="en-GB"/>
+              <a:t>Tâm Anh Oxford Partnership</a:t>
+            </a:r>
+          </a:p>
+        </p:txBody>
+      </p:sp>
+      <p:sp>
+        <p:nvSpPr>
+          <p:cNvPr id="6" name="Slide Number Placeholder 5"/>
+          <p:cNvSpPr>
+            <a:spLocks noGrp="1"/>
+          </p:cNvSpPr>
+          <p:nvPr>
+            <p:ph idx="12" sz="quarter" type="sldNum"/>
+          </p:nvPr>
+        </p:nvSpPr>
+        <p:spPr/>
+        <p:txBody>
+          <a:bodyPr/>
+          <a:lstStyle/>
+          <a:p>
+            <a:fld id="{330EA680-D336-4FF7-8B7A-9848BB0A1C32}" type="slidenum">
+              <a:rPr lang="en-GB" smtClean="0"/>
+              <a:t>‹#›</a:t>
+            </a:fld>
+            <a:endParaRPr lang="en-GB"/>
+          </a:p>
+        </p:txBody>
+      </p:sp>
     </p:spTree>
   </p:cSld>
 </p:sld>
@@ -4405,6 +4841,51 @@
           </a:p>
         </p:txBody>
       </p:sp>
+      <p:sp>
+        <p:nvSpPr>
+          <p:cNvPr id="5" name="Footer Placeholder 4"/>
+          <p:cNvSpPr>
+            <a:spLocks noGrp="1"/>
+          </p:cNvSpPr>
+          <p:nvPr>
+            <p:ph idx="11" sz="quarter" type="ftr"/>
+          </p:nvPr>
+        </p:nvSpPr>
+        <p:spPr/>
+        <p:txBody>
+          <a:bodyPr/>
+          <a:lstStyle/>
+          <a:p>
+            <a:r>
+              <a:rPr lang="en-GB"/>
+              <a:t>Tâm Anh Oxford Partnership</a:t>
+            </a:r>
+          </a:p>
+        </p:txBody>
+      </p:sp>
+      <p:sp>
+        <p:nvSpPr>
+          <p:cNvPr id="6" name="Slide Number Placeholder 5"/>
+          <p:cNvSpPr>
+            <a:spLocks noGrp="1"/>
+          </p:cNvSpPr>
+          <p:nvPr>
+            <p:ph idx="12" sz="quarter" type="sldNum"/>
+          </p:nvPr>
+        </p:nvSpPr>
+        <p:spPr/>
+        <p:txBody>
+          <a:bodyPr/>
+          <a:lstStyle/>
+          <a:p>
+            <a:fld id="{330EA680-D336-4FF7-8B7A-9848BB0A1C32}" type="slidenum">
+              <a:rPr lang="en-GB" smtClean="0"/>
+              <a:t>‹#›</a:t>
+            </a:fld>
+            <a:endParaRPr lang="en-GB"/>
+          </a:p>
+        </p:txBody>
+      </p:sp>
     </p:spTree>
   </p:cSld>
 </p:sld>
@@ -4556,6 +5037,51 @@
           </a:p>
         </p:txBody>
       </p:sp>
+      <p:sp>
+        <p:nvSpPr>
+          <p:cNvPr id="5" name="Footer Placeholder 4"/>
+          <p:cNvSpPr>
+            <a:spLocks noGrp="1"/>
+          </p:cNvSpPr>
+          <p:nvPr>
+            <p:ph idx="11" sz="quarter" type="ftr"/>
+          </p:nvPr>
+        </p:nvSpPr>
+        <p:spPr/>
+        <p:txBody>
+          <a:bodyPr/>
+          <a:lstStyle/>
+          <a:p>
+            <a:r>
+              <a:rPr lang="en-GB"/>
+              <a:t>Tâm Anh Oxford Partnership</a:t>
+            </a:r>
+          </a:p>
+        </p:txBody>
+      </p:sp>
+      <p:sp>
+        <p:nvSpPr>
+          <p:cNvPr id="6" name="Slide Number Placeholder 5"/>
+          <p:cNvSpPr>
+            <a:spLocks noGrp="1"/>
+          </p:cNvSpPr>
+          <p:nvPr>
+            <p:ph idx="12" sz="quarter" type="sldNum"/>
+          </p:nvPr>
+        </p:nvSpPr>
+        <p:spPr/>
+        <p:txBody>
+          <a:bodyPr/>
+          <a:lstStyle/>
+          <a:p>
+            <a:fld id="{330EA680-D336-4FF7-8B7A-9848BB0A1C32}" type="slidenum">
+              <a:rPr lang="en-GB" smtClean="0"/>
+              <a:t>‹#›</a:t>
+            </a:fld>
+            <a:endParaRPr lang="en-GB"/>
+          </a:p>
+        </p:txBody>
+      </p:sp>
     </p:spTree>
   </p:cSld>
 </p:sld>
@@ -4647,6 +5173,51 @@
           </a:p>
         </p:txBody>
       </p:sp>
+      <p:sp>
+        <p:nvSpPr>
+          <p:cNvPr id="5" name="Footer Placeholder 4"/>
+          <p:cNvSpPr>
+            <a:spLocks noGrp="1"/>
+          </p:cNvSpPr>
+          <p:nvPr>
+            <p:ph idx="11" sz="quarter" type="ftr"/>
+          </p:nvPr>
+        </p:nvSpPr>
+        <p:spPr/>
+        <p:txBody>
+          <a:bodyPr/>
+          <a:lstStyle/>
+          <a:p>
+            <a:r>
+              <a:rPr lang="en-GB"/>
+              <a:t>Tâm Anh Oxford Partnership</a:t>
+            </a:r>
+          </a:p>
+        </p:txBody>
+      </p:sp>
+      <p:sp>
+        <p:nvSpPr>
+          <p:cNvPr id="6" name="Slide Number Placeholder 5"/>
+          <p:cNvSpPr>
+            <a:spLocks noGrp="1"/>
+          </p:cNvSpPr>
+          <p:nvPr>
+            <p:ph idx="12" sz="quarter" type="sldNum"/>
+          </p:nvPr>
+        </p:nvSpPr>
+        <p:spPr/>
+        <p:txBody>
+          <a:bodyPr/>
+          <a:lstStyle/>
+          <a:p>
+            <a:fld id="{330EA680-D336-4FF7-8B7A-9848BB0A1C32}" type="slidenum">
+              <a:rPr lang="en-GB" smtClean="0"/>
+              <a:t>‹#›</a:t>
+            </a:fld>
+            <a:endParaRPr lang="en-GB"/>
+          </a:p>
+        </p:txBody>
+      </p:sp>
     </p:spTree>
   </p:cSld>
 </p:sld>
@@ -4710,8 +5281,8 @@
         </p:blipFill>
         <p:spPr bwMode="auto">
           <a:xfrm>
-            <a:off x="2032000" y="1193800"/>
-            <a:ext cx="5080000" cy="3390900"/>
+            <a:off x="2844800" y="1816100"/>
+            <a:ext cx="6515100" cy="4343400"/>
           </a:xfrm>
           <a:prstGeom prst="rect">
             <a:avLst/>
@@ -4724,6 +5295,51 @@
           </a:ln>
         </p:spPr>
       </p:pic>
+      <p:sp>
+        <p:nvSpPr>
+          <p:cNvPr id="5" name="Footer Placeholder 4"/>
+          <p:cNvSpPr>
+            <a:spLocks noGrp="1"/>
+          </p:cNvSpPr>
+          <p:nvPr>
+            <p:ph idx="11" sz="quarter" type="ftr"/>
+          </p:nvPr>
+        </p:nvSpPr>
+        <p:spPr/>
+        <p:txBody>
+          <a:bodyPr/>
+          <a:lstStyle/>
+          <a:p>
+            <a:r>
+              <a:rPr lang="en-GB"/>
+              <a:t>Tâm Anh Oxford Partnership</a:t>
+            </a:r>
+          </a:p>
+        </p:txBody>
+      </p:sp>
+      <p:sp>
+        <p:nvSpPr>
+          <p:cNvPr id="6" name="Slide Number Placeholder 5"/>
+          <p:cNvSpPr>
+            <a:spLocks noGrp="1"/>
+          </p:cNvSpPr>
+          <p:nvPr>
+            <p:ph idx="12" sz="quarter" type="sldNum"/>
+          </p:nvPr>
+        </p:nvSpPr>
+        <p:spPr/>
+        <p:txBody>
+          <a:bodyPr/>
+          <a:lstStyle/>
+          <a:p>
+            <a:fld id="{330EA680-D336-4FF7-8B7A-9848BB0A1C32}" type="slidenum">
+              <a:rPr lang="en-GB" smtClean="0"/>
+              <a:t>‹#›</a:t>
+            </a:fld>
+            <a:endParaRPr lang="en-GB"/>
+          </a:p>
+        </p:txBody>
+      </p:sp>
     </p:spTree>
   </p:cSld>
 </p:sld>
@@ -4771,6 +5387,51 @@
           </a:p>
         </p:txBody>
       </p:sp>
+      <p:sp>
+        <p:nvSpPr>
+          <p:cNvPr id="5" name="Footer Placeholder 4"/>
+          <p:cNvSpPr>
+            <a:spLocks noGrp="1"/>
+          </p:cNvSpPr>
+          <p:nvPr>
+            <p:ph idx="11" sz="quarter" type="ftr"/>
+          </p:nvPr>
+        </p:nvSpPr>
+        <p:spPr/>
+        <p:txBody>
+          <a:bodyPr/>
+          <a:lstStyle/>
+          <a:p>
+            <a:r>
+              <a:rPr lang="en-GB"/>
+              <a:t>Tâm Anh Oxford Partnership</a:t>
+            </a:r>
+          </a:p>
+        </p:txBody>
+      </p:sp>
+      <p:sp>
+        <p:nvSpPr>
+          <p:cNvPr id="6" name="Slide Number Placeholder 5"/>
+          <p:cNvSpPr>
+            <a:spLocks noGrp="1"/>
+          </p:cNvSpPr>
+          <p:nvPr>
+            <p:ph idx="12" sz="quarter" type="sldNum"/>
+          </p:nvPr>
+        </p:nvSpPr>
+        <p:spPr/>
+        <p:txBody>
+          <a:bodyPr/>
+          <a:lstStyle/>
+          <a:p>
+            <a:fld id="{330EA680-D336-4FF7-8B7A-9848BB0A1C32}" type="slidenum">
+              <a:rPr lang="en-GB" smtClean="0"/>
+              <a:t>‹#›</a:t>
+            </a:fld>
+            <a:endParaRPr lang="en-GB"/>
+          </a:p>
+        </p:txBody>
+      </p:sp>
     </p:spTree>
   </p:cSld>
 </p:sld>
@@ -4855,6 +5516,51 @@
           </a:p>
         </p:txBody>
       </p:sp>
+      <p:sp>
+        <p:nvSpPr>
+          <p:cNvPr id="5" name="Footer Placeholder 4"/>
+          <p:cNvSpPr>
+            <a:spLocks noGrp="1"/>
+          </p:cNvSpPr>
+          <p:nvPr>
+            <p:ph idx="11" sz="quarter" type="ftr"/>
+          </p:nvPr>
+        </p:nvSpPr>
+        <p:spPr/>
+        <p:txBody>
+          <a:bodyPr/>
+          <a:lstStyle/>
+          <a:p>
+            <a:r>
+              <a:rPr lang="en-GB"/>
+              <a:t>Tâm Anh Oxford Partnership</a:t>
+            </a:r>
+          </a:p>
+        </p:txBody>
+      </p:sp>
+      <p:sp>
+        <p:nvSpPr>
+          <p:cNvPr id="6" name="Slide Number Placeholder 5"/>
+          <p:cNvSpPr>
+            <a:spLocks noGrp="1"/>
+          </p:cNvSpPr>
+          <p:nvPr>
+            <p:ph idx="12" sz="quarter" type="sldNum"/>
+          </p:nvPr>
+        </p:nvSpPr>
+        <p:spPr/>
+        <p:txBody>
+          <a:bodyPr/>
+          <a:lstStyle/>
+          <a:p>
+            <a:fld id="{330EA680-D336-4FF7-8B7A-9848BB0A1C32}" type="slidenum">
+              <a:rPr lang="en-GB" smtClean="0"/>
+              <a:t>‹#›</a:t>
+            </a:fld>
+            <a:endParaRPr lang="en-GB"/>
+          </a:p>
+        </p:txBody>
+      </p:sp>
     </p:spTree>
   </p:cSld>
 </p:sld>
@@ -4939,6 +5645,51 @@
           </a:p>
         </p:txBody>
       </p:sp>
+      <p:sp>
+        <p:nvSpPr>
+          <p:cNvPr id="5" name="Footer Placeholder 4"/>
+          <p:cNvSpPr>
+            <a:spLocks noGrp="1"/>
+          </p:cNvSpPr>
+          <p:nvPr>
+            <p:ph idx="11" sz="quarter" type="ftr"/>
+          </p:nvPr>
+        </p:nvSpPr>
+        <p:spPr/>
+        <p:txBody>
+          <a:bodyPr/>
+          <a:lstStyle/>
+          <a:p>
+            <a:r>
+              <a:rPr lang="en-GB"/>
+              <a:t>Tâm Anh Oxford Partnership</a:t>
+            </a:r>
+          </a:p>
+        </p:txBody>
+      </p:sp>
+      <p:sp>
+        <p:nvSpPr>
+          <p:cNvPr id="6" name="Slide Number Placeholder 5"/>
+          <p:cNvSpPr>
+            <a:spLocks noGrp="1"/>
+          </p:cNvSpPr>
+          <p:nvPr>
+            <p:ph idx="12" sz="quarter" type="sldNum"/>
+          </p:nvPr>
+        </p:nvSpPr>
+        <p:spPr/>
+        <p:txBody>
+          <a:bodyPr/>
+          <a:lstStyle/>
+          <a:p>
+            <a:fld id="{330EA680-D336-4FF7-8B7A-9848BB0A1C32}" type="slidenum">
+              <a:rPr lang="en-GB" smtClean="0"/>
+              <a:t>‹#›</a:t>
+            </a:fld>
+            <a:endParaRPr lang="en-GB"/>
+          </a:p>
+        </p:txBody>
+      </p:sp>
     </p:spTree>
   </p:cSld>
 </p:sld>
@@ -5023,6 +5774,51 @@
           </a:p>
         </p:txBody>
       </p:sp>
+      <p:sp>
+        <p:nvSpPr>
+          <p:cNvPr id="5" name="Footer Placeholder 4"/>
+          <p:cNvSpPr>
+            <a:spLocks noGrp="1"/>
+          </p:cNvSpPr>
+          <p:nvPr>
+            <p:ph idx="11" sz="quarter" type="ftr"/>
+          </p:nvPr>
+        </p:nvSpPr>
+        <p:spPr/>
+        <p:txBody>
+          <a:bodyPr/>
+          <a:lstStyle/>
+          <a:p>
+            <a:r>
+              <a:rPr lang="en-GB"/>
+              <a:t>Tâm Anh Oxford Partnership</a:t>
+            </a:r>
+          </a:p>
+        </p:txBody>
+      </p:sp>
+      <p:sp>
+        <p:nvSpPr>
+          <p:cNvPr id="6" name="Slide Number Placeholder 5"/>
+          <p:cNvSpPr>
+            <a:spLocks noGrp="1"/>
+          </p:cNvSpPr>
+          <p:nvPr>
+            <p:ph idx="12" sz="quarter" type="sldNum"/>
+          </p:nvPr>
+        </p:nvSpPr>
+        <p:spPr/>
+        <p:txBody>
+          <a:bodyPr/>
+          <a:lstStyle/>
+          <a:p>
+            <a:fld id="{330EA680-D336-4FF7-8B7A-9848BB0A1C32}" type="slidenum">
+              <a:rPr lang="en-GB" smtClean="0"/>
+              <a:t>‹#›</a:t>
+            </a:fld>
+            <a:endParaRPr lang="en-GB"/>
+          </a:p>
+        </p:txBody>
+      </p:sp>
     </p:spTree>
   </p:cSld>
 </p:sld>
@@ -5107,6 +5903,51 @@
           </a:p>
         </p:txBody>
       </p:sp>
+      <p:sp>
+        <p:nvSpPr>
+          <p:cNvPr id="5" name="Footer Placeholder 4"/>
+          <p:cNvSpPr>
+            <a:spLocks noGrp="1"/>
+          </p:cNvSpPr>
+          <p:nvPr>
+            <p:ph idx="11" sz="quarter" type="ftr"/>
+          </p:nvPr>
+        </p:nvSpPr>
+        <p:spPr/>
+        <p:txBody>
+          <a:bodyPr/>
+          <a:lstStyle/>
+          <a:p>
+            <a:r>
+              <a:rPr lang="en-GB"/>
+              <a:t>Tâm Anh Oxford Partnership</a:t>
+            </a:r>
+          </a:p>
+        </p:txBody>
+      </p:sp>
+      <p:sp>
+        <p:nvSpPr>
+          <p:cNvPr id="6" name="Slide Number Placeholder 5"/>
+          <p:cNvSpPr>
+            <a:spLocks noGrp="1"/>
+          </p:cNvSpPr>
+          <p:nvPr>
+            <p:ph idx="12" sz="quarter" type="sldNum"/>
+          </p:nvPr>
+        </p:nvSpPr>
+        <p:spPr/>
+        <p:txBody>
+          <a:bodyPr/>
+          <a:lstStyle/>
+          <a:p>
+            <a:fld id="{330EA680-D336-4FF7-8B7A-9848BB0A1C32}" type="slidenum">
+              <a:rPr lang="en-GB" smtClean="0"/>
+              <a:t>‹#›</a:t>
+            </a:fld>
+            <a:endParaRPr lang="en-GB"/>
+          </a:p>
+        </p:txBody>
+      </p:sp>
     </p:spTree>
   </p:cSld>
 </p:sld>
@@ -5154,13 +5995,58 @@
           </a:p>
         </p:txBody>
       </p:sp>
+      <p:sp>
+        <p:nvSpPr>
+          <p:cNvPr id="5" name="Footer Placeholder 4"/>
+          <p:cNvSpPr>
+            <a:spLocks noGrp="1"/>
+          </p:cNvSpPr>
+          <p:nvPr>
+            <p:ph idx="11" sz="quarter" type="ftr"/>
+          </p:nvPr>
+        </p:nvSpPr>
+        <p:spPr/>
+        <p:txBody>
+          <a:bodyPr/>
+          <a:lstStyle/>
+          <a:p>
+            <a:r>
+              <a:rPr lang="en-GB"/>
+              <a:t>Tâm Anh Oxford Partnership</a:t>
+            </a:r>
+          </a:p>
+        </p:txBody>
+      </p:sp>
+      <p:sp>
+        <p:nvSpPr>
+          <p:cNvPr id="6" name="Slide Number Placeholder 5"/>
+          <p:cNvSpPr>
+            <a:spLocks noGrp="1"/>
+          </p:cNvSpPr>
+          <p:nvPr>
+            <p:ph idx="12" sz="quarter" type="sldNum"/>
+          </p:nvPr>
+        </p:nvSpPr>
+        <p:spPr/>
+        <p:txBody>
+          <a:bodyPr/>
+          <a:lstStyle/>
+          <a:p>
+            <a:fld id="{330EA680-D336-4FF7-8B7A-9848BB0A1C32}" type="slidenum">
+              <a:rPr lang="en-GB" smtClean="0"/>
+              <a:t>‹#›</a:t>
+            </a:fld>
+            <a:endParaRPr lang="en-GB"/>
+          </a:p>
+        </p:txBody>
+      </p:sp>
     </p:spTree>
   </p:cSld>
 </p:sld>
 </file>
 
 <file path=ppt/theme/theme1.xml><?xml version="1.0" encoding="utf-8"?>
-<a:theme xmlns:a="http://schemas.openxmlformats.org/drawingml/2006/main" name="Office Theme">
+<a:theme xmlns:a="http://schemas.openxmlformats.org/drawingml/2006/main" name="office theme">
   <a:themeElements>
     <a:clrScheme name="Office">
       <a:dk1>
@@ -5170,39 +6056,39 @@
         <a:sysClr val="window" lastClr="FFFFFF"/>
       </a:lt1>
       <a:dk2>
-        <a:srgbClr val="1F497D"/>
+        <a:srgbClr val="0E2841"/>
       </a:dk2>
       <a:lt2>
-        <a:srgbClr val="EEECE1"/>
+        <a:srgbClr val="E8E8E8"/>
       </a:lt2>
       <a:accent1>
-        <a:srgbClr val="4F81BD"/>
+        <a:srgbClr val="156082"/>
       </a:accent1>
       <a:accent2>
-        <a:srgbClr val="C0504D"/>
+        <a:srgbClr val="E97132"/>
       </a:accent2>
       <a:accent3>
-        <a:srgbClr val="9BBB59"/>
+        <a:srgbClr val="196B24"/>
       </a:accent3>
       <a:accent4>
-        <a:srgbClr val="8064A2"/>
+        <a:srgbClr val="0F9ED5"/>
       </a:accent4>
       <a:accent5>
-        <a:srgbClr val="4BACC6"/>
+        <a:srgbClr val="A02B93"/>
       </a:accent5>
       <a:accent6>
-        <a:srgbClr val="F79646"/>
+        <a:srgbClr val="4EA72E"/>
       </a:accent6>
       <a:hlink>
-        <a:srgbClr val="0000FF"/>
+        <a:srgbClr val="467886"/>
       </a:hlink>
       <a:folHlink>
-        <a:srgbClr val="800080"/>
+        <a:srgbClr val="96607D"/>
       </a:folHlink>
     </a:clrScheme>
-    <a:fontScheme name="Office">
+    <a:fontScheme name="Office Theme">
       <a:majorFont>
-        <a:latin typeface="Calibri"/>
+        <a:latin typeface="Aptos Display" panose="020F0302020204030204"/>
         <a:ea typeface=""/>
         <a:cs typeface=""/>
         <a:font script="Jpan" typeface="ＭＳ Ｐゴシック"/>
@@ -5237,7 +6123,7 @@
         <a:font script="Geor" typeface="Sylfaen"/>
       </a:majorFont>
       <a:minorFont>
-        <a:latin typeface="Calibri"/>
+        <a:latin typeface="Aptos" panose="020B0004020202020204"/>
         <a:ea typeface=""/>
         <a:cs typeface=""/>
         <a:font script="Jpan" typeface="ＭＳ Ｐゴシック"/>
@@ -5272,7 +6158,7 @@
         <a:font script="Geor" typeface="Sylfaen"/>
       </a:minorFont>
     </a:fontScheme>
-    <a:fmtScheme name="Office">
+    <a:fmtScheme name="Office Theme">
       <a:fillStyleLst>
         <a:solidFill>
           <a:schemeClr val="phClr"/>
@@ -5281,180 +6167,136 @@
           <a:gsLst>
             <a:gs pos="0">
               <a:schemeClr val="phClr">
-                <a:tint val="50000"/>
-                <a:satMod val="300000"/>
+                <a:lumMod val="110000"/>
+                <a:satMod val="105000"/>
+                <a:tint val="67000"/>
               </a:schemeClr>
             </a:gs>
-            <a:gs pos="35000">
+            <a:gs pos="50000">
               <a:schemeClr val="phClr">
-                <a:tint val="37000"/>
-                <a:satMod val="300000"/>
+                <a:lumMod val="105000"/>
+                <a:satMod val="103000"/>
+                <a:tint val="73000"/>
               </a:schemeClr>
             </a:gs>
             <a:gs pos="100000">
               <a:schemeClr val="phClr">
-                <a:tint val="15000"/>
-                <a:satMod val="350000"/>
+                <a:lumMod val="105000"/>
+                <a:satMod val="109000"/>
+                <a:tint val="81000"/>
               </a:schemeClr>
             </a:gs>
           </a:gsLst>
-          <a:lin ang="16200000" scaled="1"/>
+          <a:lin ang="5400000" scaled="0"/>
         </a:gradFill>
         <a:gradFill rotWithShape="1">
           <a:gsLst>
             <a:gs pos="0">
               <a:schemeClr val="phClr">
-                <a:tint val="100000"/>
+                <a:satMod val="103000"/>
+                <a:lumMod val="102000"/>
+                <a:tint val="94000"/>
+              </a:schemeClr>
+            </a:gs>
+            <a:gs pos="50000">
+              <a:schemeClr val="phClr">
+                <a:satMod val="110000"/>
+                <a:lumMod val="100000"/>
                 <a:shade val="100000"/>
-                <a:satMod val="130000"/>
               </a:schemeClr>
             </a:gs>
             <a:gs pos="100000">
               <a:schemeClr val="phClr">
-                <a:tint val="50000"/>
-                <a:shade val="100000"/>
-                <a:satMod val="350000"/>
+                <a:lumMod val="99000"/>
+                <a:satMod val="120000"/>
+                <a:shade val="78000"/>
               </a:schemeClr>
             </a:gs>
           </a:gsLst>
-          <a:lin ang="16200000" scaled="0"/>
+          <a:lin ang="5400000" scaled="0"/>
         </a:gradFill>
       </a:fillStyleLst>
       <a:lnStyleLst>
-        <a:ln w="9525" cap="flat" cmpd="sng" algn="ctr">
+        <a:ln w="12700" cap="flat" cmpd="sng" algn="ctr">
           <a:solidFill>
-            <a:schemeClr val="phClr">
-              <a:shade val="95000"/>
-              <a:satMod val="105000"/>
-            </a:schemeClr>
+            <a:schemeClr val="phClr"/>
           </a:solidFill>
           <a:prstDash val="solid"/>
+          <a:miter lim="800000"/>
+        </a:ln>
+        <a:ln w="19050" cap="flat" cmpd="sng" algn="ctr">
+          <a:solidFill>
+            <a:schemeClr val="phClr"/>
+          </a:solidFill>
+          <a:prstDash val="solid"/>
+          <a:miter lim="800000"/>
         </a:ln>
         <a:ln w="25400" cap="flat" cmpd="sng" algn="ctr">
           <a:solidFill>
             <a:schemeClr val="phClr"/>
           </a:solidFill>
           <a:prstDash val="solid"/>
-        </a:ln>
-        <a:ln w="38100" cap="flat" cmpd="sng" algn="ctr">
-          <a:solidFill>
-            <a:schemeClr val="phClr"/>
-          </a:solidFill>
-          <a:prstDash val="solid"/>
+          <a:miter lim="800000"/>
         </a:ln>
       </a:lnStyleLst>
       <a:effectStyleLst>
         <a:effectStyle>
+          <a:effectLst/>
+        </a:effectStyle>
+        <a:effectStyle>
+          <a:effectLst/>
+        </a:effectStyle>
+        <a:effectStyle>
           <a:effectLst>
-            <a:outerShdw blurRad="40000" dist="20000" dir="5400000" rotWithShape="0">
+            <a:outerShdw blurRad="57150" dist="19050" dir="5400000" algn="ctr" rotWithShape="0">
               <a:srgbClr val="000000">
-                <a:alpha val="38000"/>
+                <a:alpha val="63000"/>
               </a:srgbClr>
             </a:outerShdw>
           </a:effectLst>
-        </a:effectStyle>
-        <a:effectStyle>
-          <a:effectLst>
-            <a:outerShdw blurRad="40000" dist="23000" dir="5400000" rotWithShape="0">
-              <a:srgbClr val="000000">
-                <a:alpha val="35000"/>
-              </a:srgbClr>
-            </a:outerShdw>
-          </a:effectLst>
-        </a:effectStyle>
-        <a:effectStyle>
-          <a:effectLst>
-            <a:outerShdw blurRad="40000" dist="23000" dir="5400000" rotWithShape="0">
-              <a:srgbClr val="000000">
-                <a:alpha val="35000"/>
-              </a:srgbClr>
-            </a:outerShdw>
-          </a:effectLst>
-          <a:scene3d>
-            <a:camera prst="orthographicFront">
-              <a:rot lat="0" lon="0" rev="0"/>
-            </a:camera>
-            <a:lightRig rig="threePt" dir="t">
-              <a:rot lat="0" lon="0" rev="1200000"/>
-            </a:lightRig>
-          </a:scene3d>
-          <a:sp3d>
-            <a:bevelT w="63500" h="25400"/>
-          </a:sp3d>
         </a:effectStyle>
       </a:effectStyleLst>
       <a:bgFillStyleLst>
         <a:solidFill>
           <a:schemeClr val="phClr"/>
         </a:solidFill>
+        <a:solidFill>
+          <a:schemeClr val="phClr">
+            <a:tint val="95000"/>
+            <a:satMod val="170000"/>
+          </a:schemeClr>
+        </a:solidFill>
         <a:gradFill rotWithShape="1">
           <a:gsLst>
             <a:gs pos="0">
               <a:schemeClr val="phClr">
-                <a:tint val="40000"/>
-                <a:satMod val="350000"/>
+                <a:tint val="93000"/>
+                <a:satMod val="150000"/>
+                <a:shade val="98000"/>
+                <a:lumMod val="102000"/>
               </a:schemeClr>
             </a:gs>
-            <a:gs pos="40000">
+            <a:gs pos="50000">
               <a:schemeClr val="phClr">
-                <a:tint val="45000"/>
-                <a:shade val="99000"/>
-                <a:satMod val="350000"/>
+                <a:tint val="98000"/>
+                <a:satMod val="130000"/>
+                <a:shade val="90000"/>
+                <a:lumMod val="103000"/>
               </a:schemeClr>
             </a:gs>
             <a:gs pos="100000">
               <a:schemeClr val="phClr">
-                <a:shade val="20000"/>
-                <a:satMod val="255000"/>
+                <a:shade val="63000"/>
+                <a:satMod val="120000"/>
               </a:schemeClr>
             </a:gs>
           </a:gsLst>
-          <a:path path="circle">
-            <a:fillToRect l="50000" t="-80000" r="50000" b="180000"/>
-          </a:path>
-        </a:gradFill>
-        <a:gradFill rotWithShape="1">
-          <a:gsLst>
-            <a:gs pos="0">
-              <a:schemeClr val="phClr">
-                <a:tint val="80000"/>
-                <a:satMod val="300000"/>
-              </a:schemeClr>
-            </a:gs>
-            <a:gs pos="100000">
-              <a:schemeClr val="phClr">
-                <a:shade val="30000"/>
-                <a:satMod val="200000"/>
-              </a:schemeClr>
-            </a:gs>
-          </a:gsLst>
-          <a:path path="circle">
-            <a:fillToRect l="50000" t="50000" r="50000" b="50000"/>
-          </a:path>
+          <a:lin ang="5400000" scaled="0"/>
         </a:gradFill>
       </a:bgFillStyleLst>
     </a:fmtScheme>
   </a:themeElements>
   <a:objectDefaults>
-    <a:spDef>
-      <a:spPr/>
-      <a:bodyPr/>
-      <a:lstStyle/>
-      <a:style>
-        <a:lnRef idx="1">
-          <a:schemeClr val="accent1"/>
-        </a:lnRef>
-        <a:fillRef idx="3">
-          <a:schemeClr val="accent1"/>
-        </a:fillRef>
-        <a:effectRef idx="2">
-          <a:schemeClr val="accent1"/>
-        </a:effectRef>
-        <a:fontRef idx="minor">
-          <a:schemeClr val="lt1"/>
-        </a:fontRef>
-      </a:style>
-    </a:spDef>
     <a:lnDef>
       <a:spPr/>
       <a:bodyPr/>
@@ -5476,6 +6318,11 @@
     </a:lnDef>
   </a:objectDefaults>
   <a:extraClrSchemeLst/>
+  <a:extLst>
+    <a:ext uri="{05A4C25C-085E-4340-85A3-A5531E510DB2}">
+      <thm15:themeFamily xmlns:thm15="http://schemas.microsoft.com/office/thememl/2012/main" name="Office Theme" id="{2E142A2C-CD16-42D6-873A-C26D2A0506FA}" vid="{1BDDFF52-6CD6-40A5-AB3C-68EB2F1E4D0A}"/>
+    </a:ext>
+  </a:extLst>
 </a:theme>
 </file>
 

</xml_diff>